<commit_message>
Apply new NABD brand palette across previews, launcher and presentation
Emerald #10B981, navy #0F172A, lemon #FACC15, off-white #F8FAFC with
light and dark token sets.

Co-Authored-By: Claude Opus 5.5 <noreply@anthropic.com>
Claude-Session: https://claude.ai/code/session_01HDVkYBkoA292EVp4ibdaeY
</commit_message>
<xml_diff>
--- a/nabd/presentation/nabd-overview.pptx
+++ b/nabd/presentation/nabd-overview.pptx
@@ -1925,7 +1925,7 @@
     <p:bg>
       <p:bgPr>
         <a:solidFill>
-          <a:srgbClr val="12241F"/>
+          <a:srgbClr val="0F172A"/>
         </a:solidFill>
       </p:bgPr>
     </p:bg>
@@ -1958,11 +1958,11 @@
             <a:avLst/>
           </a:prstGeom>
           <a:solidFill>
-            <a:srgbClr val="1D6B58"/>
+            <a:srgbClr val="10B981"/>
           </a:solidFill>
           <a:ln w="12700">
             <a:solidFill>
-              <a:srgbClr val="1D6B58"/>
+              <a:srgbClr val="10B981"/>
             </a:solidFill>
             <a:prstDash val="solid"/>
           </a:ln>
@@ -2058,7 +2058,7 @@
             <a:r>
               <a:rPr lang="ar-SA" altLang="en-US" sz="2400" dirty="0">
                 <a:solidFill>
-                  <a:srgbClr val="BFE3D6"/>
+                  <a:srgbClr val="A7F3D0"/>
                 </a:solidFill>
                 <a:latin typeface="Arial" pitchFamily="34" charset="0"/>
                 <a:ea typeface="Arial" pitchFamily="34" charset="-122"/>
@@ -2097,7 +2097,7 @@
             <a:r>
               <a:rPr lang="ar-SA" altLang="en-US" sz="1500" dirty="0">
                 <a:solidFill>
-                  <a:srgbClr val="A9C4BA"/>
+                  <a:srgbClr val="CBD5E1"/>
                 </a:solidFill>
                 <a:latin typeface="Arial" pitchFamily="34" charset="0"/>
                 <a:ea typeface="Arial" pitchFamily="34" charset="-122"/>
@@ -2136,7 +2136,7 @@
             <a:r>
               <a:rPr lang="ar-SA" altLang="en-US" sz="1100" dirty="0">
                 <a:solidFill>
-                  <a:srgbClr val="7FA396"/>
+                  <a:srgbClr val="94A3B8"/>
                 </a:solidFill>
                 <a:latin typeface="Arial" pitchFamily="34" charset="0"/>
                 <a:ea typeface="Arial" pitchFamily="34" charset="-122"/>
@@ -2207,7 +2207,7 @@
             <a:r>
               <a:rPr lang="ar-SA" altLang="en-US" sz="3000" b="1" dirty="0">
                 <a:solidFill>
-                  <a:srgbClr val="12241F"/>
+                  <a:srgbClr val="0F172A"/>
                 </a:solidFill>
                 <a:latin typeface="Arial" pitchFamily="34" charset="0"/>
                 <a:ea typeface="Arial" pitchFamily="34" charset="-122"/>
@@ -2246,7 +2246,7 @@
             <a:r>
               <a:rPr lang="ar-SA" altLang="en-US" sz="1400" dirty="0">
                 <a:solidFill>
-                  <a:srgbClr val="4A5C56"/>
+                  <a:srgbClr val="475569"/>
                 </a:solidFill>
                 <a:latin typeface="Arial" pitchFamily="34" charset="0"/>
                 <a:ea typeface="Arial" pitchFamily="34" charset="-122"/>
@@ -2275,7 +2275,7 @@
           <a:noFill/>
           <a:ln w="25400">
             <a:solidFill>
-              <a:srgbClr val="D9E1DC"/>
+              <a:srgbClr val="E2E8F0"/>
             </a:solidFill>
             <a:prstDash val="solid"/>
           </a:ln>
@@ -2296,7 +2296,7 @@
             <a:avLst/>
           </a:prstGeom>
           <a:solidFill>
-            <a:srgbClr val="1D6B58"/>
+            <a:srgbClr val="10B981"/>
           </a:solidFill>
           <a:ln w="25400">
             <a:solidFill>
@@ -2333,7 +2333,7 @@
             <a:r>
               <a:rPr lang="ar-SA" altLang="en-US" sz="1100" dirty="0">
                 <a:solidFill>
-                  <a:srgbClr val="7A8A84"/>
+                  <a:srgbClr val="64748B"/>
                 </a:solidFill>
                 <a:latin typeface="Arial" pitchFamily="34" charset="0"/>
                 <a:ea typeface="Arial" pitchFamily="34" charset="-122"/>
@@ -2372,7 +2372,7 @@
             <a:r>
               <a:rPr lang="ar-SA" altLang="en-US" sz="1500" b="1" dirty="0">
                 <a:solidFill>
-                  <a:srgbClr val="12241F"/>
+                  <a:srgbClr val="0F172A"/>
                 </a:solidFill>
                 <a:latin typeface="Arial" pitchFamily="34" charset="0"/>
                 <a:ea typeface="Arial" pitchFamily="34" charset="-122"/>
@@ -2411,7 +2411,7 @@
             <a:r>
               <a:rPr lang="ar-SA" altLang="en-US" sz="1100" dirty="0">
                 <a:solidFill>
-                  <a:srgbClr val="4A5C56"/>
+                  <a:srgbClr val="475569"/>
                 </a:solidFill>
                 <a:latin typeface="Arial" pitchFamily="34" charset="0"/>
                 <a:ea typeface="Arial" pitchFamily="34" charset="-122"/>
@@ -2438,7 +2438,7 @@
             <a:avLst/>
           </a:prstGeom>
           <a:solidFill>
-            <a:srgbClr val="1D6B58"/>
+            <a:srgbClr val="10B981"/>
           </a:solidFill>
           <a:ln w="25400">
             <a:solidFill>
@@ -2475,7 +2475,7 @@
             <a:r>
               <a:rPr lang="ar-SA" altLang="en-US" sz="1100" dirty="0">
                 <a:solidFill>
-                  <a:srgbClr val="7A8A84"/>
+                  <a:srgbClr val="64748B"/>
                 </a:solidFill>
                 <a:latin typeface="Arial" pitchFamily="34" charset="0"/>
                 <a:ea typeface="Arial" pitchFamily="34" charset="-122"/>
@@ -2514,7 +2514,7 @@
             <a:r>
               <a:rPr lang="ar-SA" altLang="en-US" sz="1500" b="1" dirty="0">
                 <a:solidFill>
-                  <a:srgbClr val="12241F"/>
+                  <a:srgbClr val="0F172A"/>
                 </a:solidFill>
                 <a:latin typeface="Arial" pitchFamily="34" charset="0"/>
                 <a:ea typeface="Arial" pitchFamily="34" charset="-122"/>
@@ -2553,7 +2553,7 @@
             <a:r>
               <a:rPr lang="ar-SA" altLang="en-US" sz="1100" dirty="0">
                 <a:solidFill>
-                  <a:srgbClr val="4A5C56"/>
+                  <a:srgbClr val="475569"/>
                 </a:solidFill>
                 <a:latin typeface="Arial" pitchFamily="34" charset="0"/>
                 <a:ea typeface="Arial" pitchFamily="34" charset="-122"/>
@@ -2580,7 +2580,7 @@
             <a:avLst/>
           </a:prstGeom>
           <a:solidFill>
-            <a:srgbClr val="1D6B58"/>
+            <a:srgbClr val="10B981"/>
           </a:solidFill>
           <a:ln w="25400">
             <a:solidFill>
@@ -2617,7 +2617,7 @@
             <a:r>
               <a:rPr lang="ar-SA" altLang="en-US" sz="1100" dirty="0">
                 <a:solidFill>
-                  <a:srgbClr val="7A8A84"/>
+                  <a:srgbClr val="64748B"/>
                 </a:solidFill>
                 <a:latin typeface="Arial" pitchFamily="34" charset="0"/>
                 <a:ea typeface="Arial" pitchFamily="34" charset="-122"/>
@@ -2656,7 +2656,7 @@
             <a:r>
               <a:rPr lang="ar-SA" altLang="en-US" sz="1500" b="1" dirty="0">
                 <a:solidFill>
-                  <a:srgbClr val="12241F"/>
+                  <a:srgbClr val="0F172A"/>
                 </a:solidFill>
                 <a:latin typeface="Arial" pitchFamily="34" charset="0"/>
                 <a:ea typeface="Arial" pitchFamily="34" charset="-122"/>
@@ -2695,7 +2695,7 @@
             <a:r>
               <a:rPr lang="ar-SA" altLang="en-US" sz="1100" dirty="0">
                 <a:solidFill>
-                  <a:srgbClr val="4A5C56"/>
+                  <a:srgbClr val="475569"/>
                 </a:solidFill>
                 <a:latin typeface="Arial" pitchFamily="34" charset="0"/>
                 <a:ea typeface="Arial" pitchFamily="34" charset="-122"/>
@@ -2722,7 +2722,7 @@
             <a:avLst/>
           </a:prstGeom>
           <a:solidFill>
-            <a:srgbClr val="1D6B58"/>
+            <a:srgbClr val="10B981"/>
           </a:solidFill>
           <a:ln w="25400">
             <a:solidFill>
@@ -2759,7 +2759,7 @@
             <a:r>
               <a:rPr lang="ar-SA" altLang="en-US" sz="1100" dirty="0">
                 <a:solidFill>
-                  <a:srgbClr val="7A8A84"/>
+                  <a:srgbClr val="64748B"/>
                 </a:solidFill>
                 <a:latin typeface="Arial" pitchFamily="34" charset="0"/>
                 <a:ea typeface="Arial" pitchFamily="34" charset="-122"/>
@@ -2798,7 +2798,7 @@
             <a:r>
               <a:rPr lang="ar-SA" altLang="en-US" sz="1500" b="1" dirty="0">
                 <a:solidFill>
-                  <a:srgbClr val="12241F"/>
+                  <a:srgbClr val="0F172A"/>
                 </a:solidFill>
                 <a:latin typeface="Arial" pitchFamily="34" charset="0"/>
                 <a:ea typeface="Arial" pitchFamily="34" charset="-122"/>
@@ -2837,7 +2837,7 @@
             <a:r>
               <a:rPr lang="ar-SA" altLang="en-US" sz="1100" dirty="0">
                 <a:solidFill>
-                  <a:srgbClr val="4A5C56"/>
+                  <a:srgbClr val="475569"/>
                 </a:solidFill>
                 <a:latin typeface="Arial" pitchFamily="34" charset="0"/>
                 <a:ea typeface="Arial" pitchFamily="34" charset="-122"/>
@@ -2864,7 +2864,7 @@
             <a:avLst/>
           </a:prstGeom>
           <a:solidFill>
-            <a:srgbClr val="A8660F"/>
+            <a:srgbClr val="FACC15"/>
           </a:solidFill>
           <a:ln w="25400">
             <a:solidFill>
@@ -2901,7 +2901,7 @@
             <a:r>
               <a:rPr lang="ar-SA" altLang="en-US" sz="1100" dirty="0">
                 <a:solidFill>
-                  <a:srgbClr val="7A8A84"/>
+                  <a:srgbClr val="64748B"/>
                 </a:solidFill>
                 <a:latin typeface="Arial" pitchFamily="34" charset="0"/>
                 <a:ea typeface="Arial" pitchFamily="34" charset="-122"/>
@@ -2940,7 +2940,7 @@
             <a:r>
               <a:rPr lang="ar-SA" altLang="en-US" sz="1500" b="1" dirty="0">
                 <a:solidFill>
-                  <a:srgbClr val="12241F"/>
+                  <a:srgbClr val="0F172A"/>
                 </a:solidFill>
                 <a:latin typeface="Arial" pitchFamily="34" charset="0"/>
                 <a:ea typeface="Arial" pitchFamily="34" charset="-122"/>
@@ -2979,7 +2979,7 @@
             <a:r>
               <a:rPr lang="ar-SA" altLang="en-US" sz="1100" dirty="0">
                 <a:solidFill>
-                  <a:srgbClr val="4A5C56"/>
+                  <a:srgbClr val="475569"/>
                 </a:solidFill>
                 <a:latin typeface="Arial" pitchFamily="34" charset="0"/>
                 <a:ea typeface="Arial" pitchFamily="34" charset="-122"/>
@@ -3008,11 +3008,11 @@
             </a:avLst>
           </a:prstGeom>
           <a:solidFill>
-            <a:srgbClr val="F8EAD3"/>
+            <a:srgbClr val="FEF9C3"/>
           </a:solidFill>
           <a:ln w="12700">
             <a:solidFill>
-              <a:srgbClr val="F8EAD3"/>
+              <a:srgbClr val="FEF9C3"/>
             </a:solidFill>
             <a:prstDash val="solid"/>
           </a:ln>
@@ -3045,7 +3045,7 @@
             <a:r>
               <a:rPr lang="ar-SA" altLang="en-US" sz="1250" b="1" dirty="0">
                 <a:solidFill>
-                  <a:srgbClr val="A8660F"/>
+                  <a:srgbClr val="A16207"/>
                 </a:solidFill>
                 <a:latin typeface="Arial" pitchFamily="34" charset="0"/>
                 <a:ea typeface="Arial" pitchFamily="34" charset="-122"/>
@@ -3084,7 +3084,7 @@
             <a:r>
               <a:rPr lang="ar-SA" altLang="en-US" sz="900" dirty="0">
                 <a:solidFill>
-                  <a:srgbClr val="7A8A84"/>
+                  <a:srgbClr val="64748B"/>
                 </a:solidFill>
                 <a:latin typeface="Arial" pitchFamily="34" charset="0"/>
                 <a:ea typeface="Arial" pitchFamily="34" charset="-122"/>
@@ -3123,7 +3123,7 @@
             <a:r>
               <a:rPr lang="en-US" sz="900" dirty="0">
                 <a:solidFill>
-                  <a:srgbClr val="7A8A84"/>
+                  <a:srgbClr val="64748B"/>
                 </a:solidFill>
                 <a:latin typeface="Arial" pitchFamily="34" charset="0"/>
                 <a:ea typeface="Arial" pitchFamily="34" charset="-122"/>
@@ -3149,7 +3149,7 @@
     <p:bg>
       <p:bgPr>
         <a:solidFill>
-          <a:srgbClr val="F4F7F5"/>
+          <a:srgbClr val="F8FAFC"/>
         </a:solidFill>
       </p:bgPr>
     </p:bg>
@@ -3194,7 +3194,7 @@
             <a:r>
               <a:rPr lang="ar-SA" altLang="en-US" sz="3000" b="1" dirty="0">
                 <a:solidFill>
-                  <a:srgbClr val="12241F"/>
+                  <a:srgbClr val="0F172A"/>
                 </a:solidFill>
                 <a:latin typeface="Arial" pitchFamily="34" charset="0"/>
                 <a:ea typeface="Arial" pitchFamily="34" charset="-122"/>
@@ -3233,7 +3233,7 @@
             <a:r>
               <a:rPr lang="ar-SA" altLang="en-US" sz="1400" dirty="0">
                 <a:solidFill>
-                  <a:srgbClr val="4A5C56"/>
+                  <a:srgbClr val="475569"/>
                 </a:solidFill>
                 <a:latin typeface="Arial" pitchFamily="34" charset="0"/>
                 <a:ea typeface="Arial" pitchFamily="34" charset="-122"/>
@@ -3266,7 +3266,7 @@
           </a:solidFill>
           <a:ln w="9525">
             <a:solidFill>
-              <a:srgbClr val="D9E1DC"/>
+              <a:srgbClr val="E2E8F0"/>
             </a:solidFill>
             <a:prstDash val="solid"/>
           </a:ln>
@@ -3306,7 +3306,7 @@
             <a:r>
               <a:rPr lang="ar-SA" altLang="en-US" sz="3000" b="1" dirty="0">
                 <a:solidFill>
-                  <a:srgbClr val="1D6B58"/>
+                  <a:srgbClr val="047857"/>
                 </a:solidFill>
                 <a:latin typeface="Arial" pitchFamily="34" charset="0"/>
                 <a:ea typeface="Arial" pitchFamily="34" charset="-122"/>
@@ -3345,7 +3345,7 @@
             <a:r>
               <a:rPr lang="ar-SA" altLang="en-US" sz="1400" b="1" dirty="0">
                 <a:solidFill>
-                  <a:srgbClr val="12241F"/>
+                  <a:srgbClr val="0F172A"/>
                 </a:solidFill>
                 <a:latin typeface="Arial" pitchFamily="34" charset="0"/>
                 <a:ea typeface="Arial" pitchFamily="34" charset="-122"/>
@@ -3384,7 +3384,7 @@
             <a:r>
               <a:rPr lang="ar-SA" altLang="en-US" sz="1100" dirty="0">
                 <a:solidFill>
-                  <a:srgbClr val="4A5C56"/>
+                  <a:srgbClr val="475569"/>
                 </a:solidFill>
                 <a:latin typeface="Arial" pitchFamily="34" charset="0"/>
                 <a:ea typeface="Arial" pitchFamily="34" charset="-122"/>
@@ -3417,7 +3417,7 @@
           </a:solidFill>
           <a:ln w="9525">
             <a:solidFill>
-              <a:srgbClr val="D9E1DC"/>
+              <a:srgbClr val="E2E8F0"/>
             </a:solidFill>
             <a:prstDash val="solid"/>
           </a:ln>
@@ -3457,7 +3457,7 @@
             <a:r>
               <a:rPr lang="ar-SA" altLang="en-US" sz="3000" b="1" dirty="0">
                 <a:solidFill>
-                  <a:srgbClr val="1D6B58"/>
+                  <a:srgbClr val="047857"/>
                 </a:solidFill>
                 <a:latin typeface="Arial" pitchFamily="34" charset="0"/>
                 <a:ea typeface="Arial" pitchFamily="34" charset="-122"/>
@@ -3496,7 +3496,7 @@
             <a:r>
               <a:rPr lang="ar-SA" altLang="en-US" sz="1400" b="1" dirty="0">
                 <a:solidFill>
-                  <a:srgbClr val="12241F"/>
+                  <a:srgbClr val="0F172A"/>
                 </a:solidFill>
                 <a:latin typeface="Arial" pitchFamily="34" charset="0"/>
                 <a:ea typeface="Arial" pitchFamily="34" charset="-122"/>
@@ -3535,7 +3535,7 @@
             <a:r>
               <a:rPr lang="ar-SA" altLang="en-US" sz="1100" dirty="0">
                 <a:solidFill>
-                  <a:srgbClr val="4A5C56"/>
+                  <a:srgbClr val="475569"/>
                 </a:solidFill>
                 <a:latin typeface="Arial" pitchFamily="34" charset="0"/>
                 <a:ea typeface="Arial" pitchFamily="34" charset="-122"/>
@@ -3568,7 +3568,7 @@
           </a:solidFill>
           <a:ln w="9525">
             <a:solidFill>
-              <a:srgbClr val="D9E1DC"/>
+              <a:srgbClr val="E2E8F0"/>
             </a:solidFill>
             <a:prstDash val="solid"/>
           </a:ln>
@@ -3608,7 +3608,7 @@
             <a:r>
               <a:rPr lang="ar-SA" altLang="en-US" sz="3000" b="1" dirty="0">
                 <a:solidFill>
-                  <a:srgbClr val="1D6B58"/>
+                  <a:srgbClr val="047857"/>
                 </a:solidFill>
                 <a:latin typeface="Arial" pitchFamily="34" charset="0"/>
                 <a:ea typeface="Arial" pitchFamily="34" charset="-122"/>
@@ -3647,7 +3647,7 @@
             <a:r>
               <a:rPr lang="ar-SA" altLang="en-US" sz="1400" b="1" dirty="0">
                 <a:solidFill>
-                  <a:srgbClr val="12241F"/>
+                  <a:srgbClr val="0F172A"/>
                 </a:solidFill>
                 <a:latin typeface="Arial" pitchFamily="34" charset="0"/>
                 <a:ea typeface="Arial" pitchFamily="34" charset="-122"/>
@@ -3686,7 +3686,7 @@
             <a:r>
               <a:rPr lang="ar-SA" altLang="en-US" sz="1100" dirty="0">
                 <a:solidFill>
-                  <a:srgbClr val="4A5C56"/>
+                  <a:srgbClr val="475569"/>
                 </a:solidFill>
                 <a:latin typeface="Arial" pitchFamily="34" charset="0"/>
                 <a:ea typeface="Arial" pitchFamily="34" charset="-122"/>
@@ -3719,7 +3719,7 @@
           </a:solidFill>
           <a:ln w="9525">
             <a:solidFill>
-              <a:srgbClr val="D9E1DC"/>
+              <a:srgbClr val="E2E8F0"/>
             </a:solidFill>
             <a:prstDash val="solid"/>
           </a:ln>
@@ -3759,7 +3759,7 @@
             <a:r>
               <a:rPr lang="ar-SA" altLang="en-US" sz="3000" b="1" dirty="0">
                 <a:solidFill>
-                  <a:srgbClr val="1D6B58"/>
+                  <a:srgbClr val="047857"/>
                 </a:solidFill>
                 <a:latin typeface="Arial" pitchFamily="34" charset="0"/>
                 <a:ea typeface="Arial" pitchFamily="34" charset="-122"/>
@@ -3798,7 +3798,7 @@
             <a:r>
               <a:rPr lang="ar-SA" altLang="en-US" sz="1400" b="1" dirty="0">
                 <a:solidFill>
-                  <a:srgbClr val="12241F"/>
+                  <a:srgbClr val="0F172A"/>
                 </a:solidFill>
                 <a:latin typeface="Arial" pitchFamily="34" charset="0"/>
                 <a:ea typeface="Arial" pitchFamily="34" charset="-122"/>
@@ -3837,7 +3837,7 @@
             <a:r>
               <a:rPr lang="ar-SA" altLang="en-US" sz="1100" dirty="0">
                 <a:solidFill>
-                  <a:srgbClr val="4A5C56"/>
+                  <a:srgbClr val="475569"/>
                 </a:solidFill>
                 <a:latin typeface="Arial" pitchFamily="34" charset="0"/>
                 <a:ea typeface="Arial" pitchFamily="34" charset="-122"/>
@@ -3876,7 +3876,7 @@
             <a:r>
               <a:rPr lang="ar-SA" altLang="en-US" sz="1250" b="1" dirty="0">
                 <a:solidFill>
-                  <a:srgbClr val="12241F"/>
+                  <a:srgbClr val="0F172A"/>
                 </a:solidFill>
                 <a:latin typeface="Arial" pitchFamily="34" charset="0"/>
                 <a:ea typeface="Arial" pitchFamily="34" charset="-122"/>
@@ -3915,7 +3915,7 @@
             <a:r>
               <a:rPr lang="ar-SA" altLang="en-US" sz="900" dirty="0">
                 <a:solidFill>
-                  <a:srgbClr val="7A8A84"/>
+                  <a:srgbClr val="64748B"/>
                 </a:solidFill>
                 <a:latin typeface="Arial" pitchFamily="34" charset="0"/>
                 <a:ea typeface="Arial" pitchFamily="34" charset="-122"/>
@@ -3954,7 +3954,7 @@
             <a:r>
               <a:rPr lang="en-US" sz="900" dirty="0">
                 <a:solidFill>
-                  <a:srgbClr val="7A8A84"/>
+                  <a:srgbClr val="64748B"/>
                 </a:solidFill>
                 <a:latin typeface="Arial" pitchFamily="34" charset="0"/>
                 <a:ea typeface="Arial" pitchFamily="34" charset="-122"/>
@@ -4025,7 +4025,7 @@
             <a:r>
               <a:rPr lang="ar-SA" altLang="en-US" sz="3000" b="1" dirty="0">
                 <a:solidFill>
-                  <a:srgbClr val="12241F"/>
+                  <a:srgbClr val="0F172A"/>
                 </a:solidFill>
                 <a:latin typeface="Arial" pitchFamily="34" charset="0"/>
                 <a:ea typeface="Arial" pitchFamily="34" charset="-122"/>
@@ -4064,7 +4064,7 @@
             <a:r>
               <a:rPr lang="ar-SA" altLang="en-US" sz="1400" dirty="0">
                 <a:solidFill>
-                  <a:srgbClr val="4A5C56"/>
+                  <a:srgbClr val="475569"/>
                 </a:solidFill>
                 <a:latin typeface="Arial" pitchFamily="34" charset="0"/>
                 <a:ea typeface="Arial" pitchFamily="34" charset="-122"/>
@@ -4093,11 +4093,11 @@
             </a:avLst>
           </a:prstGeom>
           <a:solidFill>
-            <a:srgbClr val="F4F7F5"/>
+            <a:srgbClr val="F8FAFC"/>
           </a:solidFill>
           <a:ln w="12700">
             <a:solidFill>
-              <a:srgbClr val="D9E1DC"/>
+              <a:srgbClr val="E2E8F0"/>
             </a:solidFill>
             <a:prstDash val="solid"/>
           </a:ln>
@@ -4154,7 +4154,7 @@
             <a:r>
               <a:rPr lang="ar-SA" altLang="en-US" sz="1350" b="1" dirty="0">
                 <a:solidFill>
-                  <a:srgbClr val="12241F"/>
+                  <a:srgbClr val="0F172A"/>
                 </a:solidFill>
                 <a:latin typeface="Arial" pitchFamily="34" charset="0"/>
                 <a:ea typeface="Arial" pitchFamily="34" charset="-122"/>
@@ -4217,7 +4217,7 @@
             <a:r>
               <a:rPr lang="ar-SA" altLang="en-US" sz="1150" dirty="0">
                 <a:solidFill>
-                  <a:srgbClr val="4A5C56"/>
+                  <a:srgbClr val="475569"/>
                 </a:solidFill>
                 <a:latin typeface="Arial" pitchFamily="34" charset="0"/>
                 <a:ea typeface="Arial" pitchFamily="34" charset="-122"/>
@@ -4250,7 +4250,7 @@
           </a:solidFill>
           <a:ln w="12700">
             <a:solidFill>
-              <a:srgbClr val="D9E1DC"/>
+              <a:srgbClr val="E2E8F0"/>
             </a:solidFill>
             <a:prstDash val="solid"/>
           </a:ln>
@@ -4307,7 +4307,7 @@
             <a:r>
               <a:rPr lang="ar-SA" altLang="en-US" sz="1350" b="1" dirty="0">
                 <a:solidFill>
-                  <a:srgbClr val="12241F"/>
+                  <a:srgbClr val="0F172A"/>
                 </a:solidFill>
                 <a:latin typeface="Arial" pitchFamily="34" charset="0"/>
                 <a:ea typeface="Arial" pitchFamily="34" charset="-122"/>
@@ -4370,7 +4370,7 @@
             <a:r>
               <a:rPr lang="ar-SA" altLang="en-US" sz="1150" dirty="0">
                 <a:solidFill>
-                  <a:srgbClr val="4A5C56"/>
+                  <a:srgbClr val="475569"/>
                 </a:solidFill>
                 <a:latin typeface="Arial" pitchFamily="34" charset="0"/>
                 <a:ea typeface="Arial" pitchFamily="34" charset="-122"/>
@@ -4399,11 +4399,11 @@
             </a:avLst>
           </a:prstGeom>
           <a:solidFill>
-            <a:srgbClr val="F4F7F5"/>
+            <a:srgbClr val="F8FAFC"/>
           </a:solidFill>
           <a:ln w="12700">
             <a:solidFill>
-              <a:srgbClr val="D9E1DC"/>
+              <a:srgbClr val="E2E8F0"/>
             </a:solidFill>
             <a:prstDash val="solid"/>
           </a:ln>
@@ -4460,7 +4460,7 @@
             <a:r>
               <a:rPr lang="ar-SA" altLang="en-US" sz="1350" b="1" dirty="0">
                 <a:solidFill>
-                  <a:srgbClr val="12241F"/>
+                  <a:srgbClr val="0F172A"/>
                 </a:solidFill>
                 <a:latin typeface="Arial" pitchFamily="34" charset="0"/>
                 <a:ea typeface="Arial" pitchFamily="34" charset="-122"/>
@@ -4523,7 +4523,7 @@
             <a:r>
               <a:rPr lang="ar-SA" altLang="en-US" sz="1150" dirty="0">
                 <a:solidFill>
-                  <a:srgbClr val="4A5C56"/>
+                  <a:srgbClr val="475569"/>
                 </a:solidFill>
                 <a:latin typeface="Arial" pitchFamily="34" charset="0"/>
                 <a:ea typeface="Arial" pitchFamily="34" charset="-122"/>
@@ -4556,7 +4556,7 @@
           </a:solidFill>
           <a:ln w="12700">
             <a:solidFill>
-              <a:srgbClr val="D9E1DC"/>
+              <a:srgbClr val="E2E8F0"/>
             </a:solidFill>
             <a:prstDash val="solid"/>
           </a:ln>
@@ -4613,7 +4613,7 @@
             <a:r>
               <a:rPr lang="ar-SA" altLang="en-US" sz="1350" b="1" dirty="0">
                 <a:solidFill>
-                  <a:srgbClr val="12241F"/>
+                  <a:srgbClr val="0F172A"/>
                 </a:solidFill>
                 <a:latin typeface="Arial" pitchFamily="34" charset="0"/>
                 <a:ea typeface="Arial" pitchFamily="34" charset="-122"/>
@@ -4676,7 +4676,7 @@
             <a:r>
               <a:rPr lang="ar-SA" altLang="en-US" sz="1150" dirty="0">
                 <a:solidFill>
-                  <a:srgbClr val="4A5C56"/>
+                  <a:srgbClr val="475569"/>
                 </a:solidFill>
                 <a:latin typeface="Arial" pitchFamily="34" charset="0"/>
                 <a:ea typeface="Arial" pitchFamily="34" charset="-122"/>
@@ -4715,7 +4715,7 @@
             <a:r>
               <a:rPr lang="ar-SA" altLang="en-US" sz="900" dirty="0">
                 <a:solidFill>
-                  <a:srgbClr val="7A8A84"/>
+                  <a:srgbClr val="64748B"/>
                 </a:solidFill>
                 <a:latin typeface="Arial" pitchFamily="34" charset="0"/>
                 <a:ea typeface="Arial" pitchFamily="34" charset="-122"/>
@@ -4754,7 +4754,7 @@
             <a:r>
               <a:rPr lang="en-US" sz="900" dirty="0">
                 <a:solidFill>
-                  <a:srgbClr val="7A8A84"/>
+                  <a:srgbClr val="64748B"/>
                 </a:solidFill>
                 <a:latin typeface="Arial" pitchFamily="34" charset="0"/>
                 <a:ea typeface="Arial" pitchFamily="34" charset="-122"/>
@@ -4780,7 +4780,7 @@
     <p:bg>
       <p:bgPr>
         <a:solidFill>
-          <a:srgbClr val="12241F"/>
+          <a:srgbClr val="0F172A"/>
         </a:solidFill>
       </p:bgPr>
     </p:bg>
@@ -4813,11 +4813,11 @@
             <a:avLst/>
           </a:prstGeom>
           <a:solidFill>
-            <a:srgbClr val="1D6B58"/>
+            <a:srgbClr val="10B981"/>
           </a:solidFill>
           <a:ln w="12700">
             <a:solidFill>
-              <a:srgbClr val="1D6B58"/>
+              <a:srgbClr val="10B981"/>
             </a:solidFill>
             <a:prstDash val="solid"/>
           </a:ln>
@@ -4901,11 +4901,11 @@
             <a:avLst/>
           </a:prstGeom>
           <a:solidFill>
-            <a:srgbClr val="2E8A73"/>
+            <a:srgbClr val="34D399"/>
           </a:solidFill>
           <a:ln w="12700">
             <a:solidFill>
-              <a:srgbClr val="2E8A73"/>
+              <a:srgbClr val="34D399"/>
             </a:solidFill>
             <a:prstDash val="solid"/>
           </a:ln>
@@ -4938,7 +4938,7 @@
             <a:r>
               <a:rPr lang="ar-SA" altLang="en-US" sz="1600" dirty="0">
                 <a:solidFill>
-                  <a:srgbClr val="D6EAE2"/>
+                  <a:srgbClr val="E2E8F0"/>
                 </a:solidFill>
                 <a:latin typeface="Arial" pitchFamily="34" charset="0"/>
                 <a:ea typeface="Arial" pitchFamily="34" charset="-122"/>
@@ -4965,11 +4965,11 @@
             <a:avLst/>
           </a:prstGeom>
           <a:solidFill>
-            <a:srgbClr val="2E8A73"/>
+            <a:srgbClr val="34D399"/>
           </a:solidFill>
           <a:ln w="12700">
             <a:solidFill>
-              <a:srgbClr val="2E8A73"/>
+              <a:srgbClr val="34D399"/>
             </a:solidFill>
             <a:prstDash val="solid"/>
           </a:ln>
@@ -5002,7 +5002,7 @@
             <a:r>
               <a:rPr lang="ar-SA" altLang="en-US" sz="1600" dirty="0">
                 <a:solidFill>
-                  <a:srgbClr val="D6EAE2"/>
+                  <a:srgbClr val="E2E8F0"/>
                 </a:solidFill>
                 <a:latin typeface="Arial" pitchFamily="34" charset="0"/>
                 <a:ea typeface="Arial" pitchFamily="34" charset="-122"/>
@@ -5029,11 +5029,11 @@
             <a:avLst/>
           </a:prstGeom>
           <a:solidFill>
-            <a:srgbClr val="2E8A73"/>
+            <a:srgbClr val="34D399"/>
           </a:solidFill>
           <a:ln w="12700">
             <a:solidFill>
-              <a:srgbClr val="2E8A73"/>
+              <a:srgbClr val="34D399"/>
             </a:solidFill>
             <a:prstDash val="solid"/>
           </a:ln>
@@ -5066,7 +5066,7 @@
             <a:r>
               <a:rPr lang="ar-SA" altLang="en-US" sz="1600" dirty="0">
                 <a:solidFill>
-                  <a:srgbClr val="D6EAE2"/>
+                  <a:srgbClr val="E2E8F0"/>
                 </a:solidFill>
                 <a:latin typeface="Arial" pitchFamily="34" charset="0"/>
                 <a:ea typeface="Arial" pitchFamily="34" charset="-122"/>
@@ -5093,11 +5093,11 @@
             <a:avLst/>
           </a:prstGeom>
           <a:solidFill>
-            <a:srgbClr val="2E8A73"/>
+            <a:srgbClr val="34D399"/>
           </a:solidFill>
           <a:ln w="12700">
             <a:solidFill>
-              <a:srgbClr val="2E8A73"/>
+              <a:srgbClr val="34D399"/>
             </a:solidFill>
             <a:prstDash val="solid"/>
           </a:ln>
@@ -5130,7 +5130,7 @@
             <a:r>
               <a:rPr lang="ar-SA" altLang="en-US" sz="1600" dirty="0">
                 <a:solidFill>
-                  <a:srgbClr val="D6EAE2"/>
+                  <a:srgbClr val="E2E8F0"/>
                 </a:solidFill>
                 <a:latin typeface="Arial" pitchFamily="34" charset="0"/>
                 <a:ea typeface="Arial" pitchFamily="34" charset="-122"/>
@@ -5169,7 +5169,7 @@
             <a:r>
               <a:rPr lang="ar-SA" altLang="en-US" sz="1400" i="1" dirty="0">
                 <a:solidFill>
-                  <a:srgbClr val="BFE3D6"/>
+                  <a:srgbClr val="A7F3D0"/>
                 </a:solidFill>
                 <a:latin typeface="Arial" pitchFamily="34" charset="0"/>
                 <a:ea typeface="Arial" pitchFamily="34" charset="-122"/>
@@ -5240,7 +5240,7 @@
             <a:r>
               <a:rPr lang="ar-SA" altLang="en-US" sz="3000" b="1" dirty="0">
                 <a:solidFill>
-                  <a:srgbClr val="12241F"/>
+                  <a:srgbClr val="0F172A"/>
                 </a:solidFill>
                 <a:latin typeface="Arial" pitchFamily="34" charset="0"/>
                 <a:ea typeface="Arial" pitchFamily="34" charset="-122"/>
@@ -5279,7 +5279,7 @@
             <a:r>
               <a:rPr lang="ar-SA" altLang="en-US" sz="1400" dirty="0">
                 <a:solidFill>
-                  <a:srgbClr val="4A5C56"/>
+                  <a:srgbClr val="475569"/>
                 </a:solidFill>
                 <a:latin typeface="Arial" pitchFamily="34" charset="0"/>
                 <a:ea typeface="Arial" pitchFamily="34" charset="-122"/>
@@ -5308,11 +5308,11 @@
             </a:avLst>
           </a:prstGeom>
           <a:solidFill>
-            <a:srgbClr val="F4F7F5"/>
+            <a:srgbClr val="F8FAFC"/>
           </a:solidFill>
           <a:ln w="9525">
             <a:solidFill>
-              <a:srgbClr val="D9E1DC"/>
+              <a:srgbClr val="E2E8F0"/>
             </a:solidFill>
             <a:prstDash val="solid"/>
           </a:ln>
@@ -5340,11 +5340,11 @@
             <a:avLst/>
           </a:prstGeom>
           <a:solidFill>
-            <a:srgbClr val="DCEDE6"/>
+            <a:srgbClr val="D1FAE5"/>
           </a:solidFill>
           <a:ln w="12700">
             <a:solidFill>
-              <a:srgbClr val="DCEDE6"/>
+              <a:srgbClr val="D1FAE5"/>
             </a:solidFill>
             <a:prstDash val="solid"/>
           </a:ln>
@@ -5401,7 +5401,7 @@
             <a:r>
               <a:rPr lang="ar-SA" altLang="en-US" sz="1700" b="1" dirty="0">
                 <a:solidFill>
-                  <a:srgbClr val="12241F"/>
+                  <a:srgbClr val="0F172A"/>
                 </a:solidFill>
                 <a:latin typeface="Arial" pitchFamily="34" charset="0"/>
                 <a:ea typeface="Arial" pitchFamily="34" charset="-122"/>
@@ -5440,7 +5440,7 @@
             <a:r>
               <a:rPr lang="ar-SA" altLang="en-US" sz="1250" dirty="0">
                 <a:solidFill>
-                  <a:srgbClr val="4A5C56"/>
+                  <a:srgbClr val="475569"/>
                 </a:solidFill>
                 <a:latin typeface="Arial" pitchFamily="34" charset="0"/>
                 <a:ea typeface="Arial" pitchFamily="34" charset="-122"/>
@@ -5469,11 +5469,11 @@
             </a:avLst>
           </a:prstGeom>
           <a:solidFill>
-            <a:srgbClr val="F4F7F5"/>
+            <a:srgbClr val="F8FAFC"/>
           </a:solidFill>
           <a:ln w="9525">
             <a:solidFill>
-              <a:srgbClr val="D9E1DC"/>
+              <a:srgbClr val="E2E8F0"/>
             </a:solidFill>
             <a:prstDash val="solid"/>
           </a:ln>
@@ -5501,11 +5501,11 @@
             <a:avLst/>
           </a:prstGeom>
           <a:solidFill>
-            <a:srgbClr val="DCEDE6"/>
+            <a:srgbClr val="D1FAE5"/>
           </a:solidFill>
           <a:ln w="12700">
             <a:solidFill>
-              <a:srgbClr val="DCEDE6"/>
+              <a:srgbClr val="D1FAE5"/>
             </a:solidFill>
             <a:prstDash val="solid"/>
           </a:ln>
@@ -5562,7 +5562,7 @@
             <a:r>
               <a:rPr lang="ar-SA" altLang="en-US" sz="1700" b="1" dirty="0">
                 <a:solidFill>
-                  <a:srgbClr val="12241F"/>
+                  <a:srgbClr val="0F172A"/>
                 </a:solidFill>
                 <a:latin typeface="Arial" pitchFamily="34" charset="0"/>
                 <a:ea typeface="Arial" pitchFamily="34" charset="-122"/>
@@ -5601,7 +5601,7 @@
             <a:r>
               <a:rPr lang="ar-SA" altLang="en-US" sz="1250" dirty="0">
                 <a:solidFill>
-                  <a:srgbClr val="4A5C56"/>
+                  <a:srgbClr val="475569"/>
                 </a:solidFill>
                 <a:latin typeface="Arial" pitchFamily="34" charset="0"/>
                 <a:ea typeface="Arial" pitchFamily="34" charset="-122"/>
@@ -5630,11 +5630,11 @@
             </a:avLst>
           </a:prstGeom>
           <a:solidFill>
-            <a:srgbClr val="F4F7F5"/>
+            <a:srgbClr val="F8FAFC"/>
           </a:solidFill>
           <a:ln w="9525">
             <a:solidFill>
-              <a:srgbClr val="D9E1DC"/>
+              <a:srgbClr val="E2E8F0"/>
             </a:solidFill>
             <a:prstDash val="solid"/>
           </a:ln>
@@ -5662,11 +5662,11 @@
             <a:avLst/>
           </a:prstGeom>
           <a:solidFill>
-            <a:srgbClr val="DCEDE6"/>
+            <a:srgbClr val="D1FAE5"/>
           </a:solidFill>
           <a:ln w="12700">
             <a:solidFill>
-              <a:srgbClr val="DCEDE6"/>
+              <a:srgbClr val="D1FAE5"/>
             </a:solidFill>
             <a:prstDash val="solid"/>
           </a:ln>
@@ -5723,7 +5723,7 @@
             <a:r>
               <a:rPr lang="ar-SA" altLang="en-US" sz="1700" b="1" dirty="0">
                 <a:solidFill>
-                  <a:srgbClr val="12241F"/>
+                  <a:srgbClr val="0F172A"/>
                 </a:solidFill>
                 <a:latin typeface="Arial" pitchFamily="34" charset="0"/>
                 <a:ea typeface="Arial" pitchFamily="34" charset="-122"/>
@@ -5762,7 +5762,7 @@
             <a:r>
               <a:rPr lang="ar-SA" altLang="en-US" sz="1250" dirty="0">
                 <a:solidFill>
-                  <a:srgbClr val="4A5C56"/>
+                  <a:srgbClr val="475569"/>
                 </a:solidFill>
                 <a:latin typeface="Arial" pitchFamily="34" charset="0"/>
                 <a:ea typeface="Arial" pitchFamily="34" charset="-122"/>
@@ -5791,11 +5791,11 @@
             </a:avLst>
           </a:prstGeom>
           <a:solidFill>
-            <a:srgbClr val="F4F7F5"/>
+            <a:srgbClr val="F8FAFC"/>
           </a:solidFill>
           <a:ln w="9525">
             <a:solidFill>
-              <a:srgbClr val="D9E1DC"/>
+              <a:srgbClr val="E2E8F0"/>
             </a:solidFill>
             <a:prstDash val="solid"/>
           </a:ln>
@@ -5823,11 +5823,11 @@
             <a:avLst/>
           </a:prstGeom>
           <a:solidFill>
-            <a:srgbClr val="DCEDE6"/>
+            <a:srgbClr val="D1FAE5"/>
           </a:solidFill>
           <a:ln w="12700">
             <a:solidFill>
-              <a:srgbClr val="DCEDE6"/>
+              <a:srgbClr val="D1FAE5"/>
             </a:solidFill>
             <a:prstDash val="solid"/>
           </a:ln>
@@ -5884,7 +5884,7 @@
             <a:r>
               <a:rPr lang="ar-SA" altLang="en-US" sz="1700" b="1" dirty="0">
                 <a:solidFill>
-                  <a:srgbClr val="12241F"/>
+                  <a:srgbClr val="0F172A"/>
                 </a:solidFill>
                 <a:latin typeface="Arial" pitchFamily="34" charset="0"/>
                 <a:ea typeface="Arial" pitchFamily="34" charset="-122"/>
@@ -5923,7 +5923,7 @@
             <a:r>
               <a:rPr lang="ar-SA" altLang="en-US" sz="1250" dirty="0">
                 <a:solidFill>
-                  <a:srgbClr val="4A5C56"/>
+                  <a:srgbClr val="475569"/>
                 </a:solidFill>
                 <a:latin typeface="Arial" pitchFamily="34" charset="0"/>
                 <a:ea typeface="Arial" pitchFamily="34" charset="-122"/>
@@ -5962,7 +5962,7 @@
             <a:r>
               <a:rPr lang="ar-SA" altLang="en-US" sz="900" dirty="0">
                 <a:solidFill>
-                  <a:srgbClr val="7A8A84"/>
+                  <a:srgbClr val="64748B"/>
                 </a:solidFill>
                 <a:latin typeface="Arial" pitchFamily="34" charset="0"/>
                 <a:ea typeface="Arial" pitchFamily="34" charset="-122"/>
@@ -6001,7 +6001,7 @@
             <a:r>
               <a:rPr lang="en-US" sz="900" dirty="0">
                 <a:solidFill>
-                  <a:srgbClr val="7A8A84"/>
+                  <a:srgbClr val="64748B"/>
                 </a:solidFill>
                 <a:latin typeface="Arial" pitchFamily="34" charset="0"/>
                 <a:ea typeface="Arial" pitchFamily="34" charset="-122"/>
@@ -6072,7 +6072,7 @@
             <a:r>
               <a:rPr lang="ar-SA" altLang="en-US" sz="3000" b="1" dirty="0">
                 <a:solidFill>
-                  <a:srgbClr val="12241F"/>
+                  <a:srgbClr val="0F172A"/>
                 </a:solidFill>
                 <a:latin typeface="Arial" pitchFamily="34" charset="0"/>
                 <a:ea typeface="Arial" pitchFamily="34" charset="-122"/>
@@ -6111,7 +6111,7 @@
             <a:r>
               <a:rPr lang="ar-SA" altLang="en-US" sz="1400" dirty="0">
                 <a:solidFill>
-                  <a:srgbClr val="4A5C56"/>
+                  <a:srgbClr val="475569"/>
                 </a:solidFill>
                 <a:latin typeface="Arial" pitchFamily="34" charset="0"/>
                 <a:ea typeface="Arial" pitchFamily="34" charset="-122"/>
@@ -6140,11 +6140,11 @@
             </a:avLst>
           </a:prstGeom>
           <a:solidFill>
-            <a:srgbClr val="F4F7F5"/>
+            <a:srgbClr val="F8FAFC"/>
           </a:solidFill>
           <a:ln w="9525">
             <a:solidFill>
-              <a:srgbClr val="D9E1DC"/>
+              <a:srgbClr val="E2E8F0"/>
             </a:solidFill>
             <a:prstDash val="solid"/>
           </a:ln>
@@ -6184,7 +6184,7 @@
             <a:r>
               <a:rPr lang="ar-SA" altLang="en-US" sz="1600" b="1" dirty="0">
                 <a:solidFill>
-                  <a:srgbClr val="7A8A84"/>
+                  <a:srgbClr val="64748B"/>
                 </a:solidFill>
                 <a:latin typeface="Arial" pitchFamily="34" charset="0"/>
                 <a:ea typeface="Arial" pitchFamily="34" charset="-122"/>
@@ -6211,11 +6211,11 @@
             <a:avLst/>
           </a:prstGeom>
           <a:solidFill>
-            <a:srgbClr val="7A8A84"/>
+            <a:srgbClr val="64748B"/>
           </a:solidFill>
           <a:ln w="12700">
             <a:solidFill>
-              <a:srgbClr val="7A8A84"/>
+              <a:srgbClr val="64748B"/>
             </a:solidFill>
             <a:prstDash val="solid"/>
           </a:ln>
@@ -6248,7 +6248,7 @@
             <a:r>
               <a:rPr lang="ar-SA" altLang="en-US" sz="1400" dirty="0">
                 <a:solidFill>
-                  <a:srgbClr val="4A5C56"/>
+                  <a:srgbClr val="475569"/>
                 </a:solidFill>
                 <a:latin typeface="Arial" pitchFamily="34" charset="0"/>
                 <a:ea typeface="Arial" pitchFamily="34" charset="-122"/>
@@ -6275,11 +6275,11 @@
             <a:avLst/>
           </a:prstGeom>
           <a:solidFill>
-            <a:srgbClr val="7A8A84"/>
+            <a:srgbClr val="64748B"/>
           </a:solidFill>
           <a:ln w="12700">
             <a:solidFill>
-              <a:srgbClr val="7A8A84"/>
+              <a:srgbClr val="64748B"/>
             </a:solidFill>
             <a:prstDash val="solid"/>
           </a:ln>
@@ -6312,7 +6312,7 @@
             <a:r>
               <a:rPr lang="ar-SA" altLang="en-US" sz="1400" dirty="0">
                 <a:solidFill>
-                  <a:srgbClr val="4A5C56"/>
+                  <a:srgbClr val="475569"/>
                 </a:solidFill>
                 <a:latin typeface="Arial" pitchFamily="34" charset="0"/>
                 <a:ea typeface="Arial" pitchFamily="34" charset="-122"/>
@@ -6339,11 +6339,11 @@
             <a:avLst/>
           </a:prstGeom>
           <a:solidFill>
-            <a:srgbClr val="7A8A84"/>
+            <a:srgbClr val="64748B"/>
           </a:solidFill>
           <a:ln w="12700">
             <a:solidFill>
-              <a:srgbClr val="7A8A84"/>
+              <a:srgbClr val="64748B"/>
             </a:solidFill>
             <a:prstDash val="solid"/>
           </a:ln>
@@ -6376,7 +6376,7 @@
             <a:r>
               <a:rPr lang="ar-SA" altLang="en-US" sz="1400" dirty="0">
                 <a:solidFill>
-                  <a:srgbClr val="4A5C56"/>
+                  <a:srgbClr val="475569"/>
                 </a:solidFill>
                 <a:latin typeface="Arial" pitchFamily="34" charset="0"/>
                 <a:ea typeface="Arial" pitchFamily="34" charset="-122"/>
@@ -6403,11 +6403,11 @@
             <a:avLst/>
           </a:prstGeom>
           <a:solidFill>
-            <a:srgbClr val="7A8A84"/>
+            <a:srgbClr val="64748B"/>
           </a:solidFill>
           <a:ln w="12700">
             <a:solidFill>
-              <a:srgbClr val="7A8A84"/>
+              <a:srgbClr val="64748B"/>
             </a:solidFill>
             <a:prstDash val="solid"/>
           </a:ln>
@@ -6440,7 +6440,7 @@
             <a:r>
               <a:rPr lang="ar-SA" altLang="en-US" sz="1400" dirty="0">
                 <a:solidFill>
-                  <a:srgbClr val="4A5C56"/>
+                  <a:srgbClr val="475569"/>
                 </a:solidFill>
                 <a:latin typeface="Arial" pitchFamily="34" charset="0"/>
                 <a:ea typeface="Arial" pitchFamily="34" charset="-122"/>
@@ -6467,11 +6467,11 @@
             <a:avLst/>
           </a:prstGeom>
           <a:solidFill>
-            <a:srgbClr val="7A8A84"/>
+            <a:srgbClr val="64748B"/>
           </a:solidFill>
           <a:ln w="12700">
             <a:solidFill>
-              <a:srgbClr val="7A8A84"/>
+              <a:srgbClr val="64748B"/>
             </a:solidFill>
             <a:prstDash val="solid"/>
           </a:ln>
@@ -6504,7 +6504,7 @@
             <a:r>
               <a:rPr lang="ar-SA" altLang="en-US" sz="1400" dirty="0">
                 <a:solidFill>
-                  <a:srgbClr val="4A5C56"/>
+                  <a:srgbClr val="475569"/>
                 </a:solidFill>
                 <a:latin typeface="Arial" pitchFamily="34" charset="0"/>
                 <a:ea typeface="Arial" pitchFamily="34" charset="-122"/>
@@ -6533,11 +6533,11 @@
             </a:avLst>
           </a:prstGeom>
           <a:solidFill>
-            <a:srgbClr val="1D6B58"/>
+            <a:srgbClr val="0F172A"/>
           </a:solidFill>
           <a:ln w="12700">
             <a:solidFill>
-              <a:srgbClr val="1D6B58"/>
+              <a:srgbClr val="0F172A"/>
             </a:solidFill>
             <a:prstDash val="solid"/>
           </a:ln>
@@ -6570,7 +6570,7 @@
             <a:r>
               <a:rPr lang="ar-SA" altLang="en-US" sz="1600" b="1" dirty="0">
                 <a:solidFill>
-                  <a:srgbClr val="FFFFFF"/>
+                  <a:srgbClr val="34D399"/>
                 </a:solidFill>
                 <a:latin typeface="Arial" pitchFamily="34" charset="0"/>
                 <a:ea typeface="Arial" pitchFamily="34" charset="-122"/>
@@ -6597,11 +6597,11 @@
             <a:avLst/>
           </a:prstGeom>
           <a:solidFill>
-            <a:srgbClr val="BFE3D6"/>
+            <a:srgbClr val="10B981"/>
           </a:solidFill>
           <a:ln w="12700">
             <a:solidFill>
-              <a:srgbClr val="BFE3D6"/>
+              <a:srgbClr val="10B981"/>
             </a:solidFill>
             <a:prstDash val="solid"/>
           </a:ln>
@@ -6661,11 +6661,11 @@
             <a:avLst/>
           </a:prstGeom>
           <a:solidFill>
-            <a:srgbClr val="BFE3D6"/>
+            <a:srgbClr val="10B981"/>
           </a:solidFill>
           <a:ln w="12700">
             <a:solidFill>
-              <a:srgbClr val="BFE3D6"/>
+              <a:srgbClr val="10B981"/>
             </a:solidFill>
             <a:prstDash val="solid"/>
           </a:ln>
@@ -6725,11 +6725,11 @@
             <a:avLst/>
           </a:prstGeom>
           <a:solidFill>
-            <a:srgbClr val="BFE3D6"/>
+            <a:srgbClr val="10B981"/>
           </a:solidFill>
           <a:ln w="12700">
             <a:solidFill>
-              <a:srgbClr val="BFE3D6"/>
+              <a:srgbClr val="10B981"/>
             </a:solidFill>
             <a:prstDash val="solid"/>
           </a:ln>
@@ -6789,11 +6789,11 @@
             <a:avLst/>
           </a:prstGeom>
           <a:solidFill>
-            <a:srgbClr val="BFE3D6"/>
+            <a:srgbClr val="10B981"/>
           </a:solidFill>
           <a:ln w="12700">
             <a:solidFill>
-              <a:srgbClr val="BFE3D6"/>
+              <a:srgbClr val="10B981"/>
             </a:solidFill>
             <a:prstDash val="solid"/>
           </a:ln>
@@ -6853,11 +6853,11 @@
             <a:avLst/>
           </a:prstGeom>
           <a:solidFill>
-            <a:srgbClr val="BFE3D6"/>
+            <a:srgbClr val="10B981"/>
           </a:solidFill>
           <a:ln w="12700">
             <a:solidFill>
-              <a:srgbClr val="BFE3D6"/>
+              <a:srgbClr val="10B981"/>
             </a:solidFill>
             <a:prstDash val="solid"/>
           </a:ln>
@@ -6929,7 +6929,7 @@
             <a:r>
               <a:rPr lang="ar-SA" altLang="en-US" sz="900" dirty="0">
                 <a:solidFill>
-                  <a:srgbClr val="7A8A84"/>
+                  <a:srgbClr val="64748B"/>
                 </a:solidFill>
                 <a:latin typeface="Arial" pitchFamily="34" charset="0"/>
                 <a:ea typeface="Arial" pitchFamily="34" charset="-122"/>
@@ -6968,7 +6968,7 @@
             <a:r>
               <a:rPr lang="en-US" sz="900" dirty="0">
                 <a:solidFill>
-                  <a:srgbClr val="7A8A84"/>
+                  <a:srgbClr val="64748B"/>
                 </a:solidFill>
                 <a:latin typeface="Arial" pitchFamily="34" charset="0"/>
                 <a:ea typeface="Arial" pitchFamily="34" charset="-122"/>
@@ -6994,7 +6994,7 @@
     <p:bg>
       <p:bgPr>
         <a:solidFill>
-          <a:srgbClr val="F4F7F5"/>
+          <a:srgbClr val="F8FAFC"/>
         </a:solidFill>
       </p:bgPr>
     </p:bg>
@@ -7039,7 +7039,7 @@
             <a:r>
               <a:rPr lang="ar-SA" altLang="en-US" sz="3000" b="1" dirty="0">
                 <a:solidFill>
-                  <a:srgbClr val="12241F"/>
+                  <a:srgbClr val="0F172A"/>
                 </a:solidFill>
                 <a:latin typeface="Arial" pitchFamily="34" charset="0"/>
                 <a:ea typeface="Arial" pitchFamily="34" charset="-122"/>
@@ -7078,7 +7078,7 @@
             <a:r>
               <a:rPr lang="ar-SA" altLang="en-US" sz="1400" dirty="0">
                 <a:solidFill>
-                  <a:srgbClr val="4A5C56"/>
+                  <a:srgbClr val="475569"/>
                 </a:solidFill>
                 <a:latin typeface="Arial" pitchFamily="34" charset="0"/>
                 <a:ea typeface="Arial" pitchFamily="34" charset="-122"/>
@@ -7105,11 +7105,11 @@
             <a:avLst/>
           </a:prstGeom>
           <a:solidFill>
-            <a:srgbClr val="1D6B58"/>
+            <a:srgbClr val="10B981"/>
           </a:solidFill>
           <a:ln w="12700">
             <a:solidFill>
-              <a:srgbClr val="1D6B58"/>
+              <a:srgbClr val="10B981"/>
             </a:solidFill>
             <a:prstDash val="solid"/>
           </a:ln>
@@ -7166,7 +7166,7 @@
             <a:r>
               <a:rPr lang="ar-SA" altLang="en-US" sz="1500" b="1" dirty="0">
                 <a:solidFill>
-                  <a:srgbClr val="12241F"/>
+                  <a:srgbClr val="0F172A"/>
                 </a:solidFill>
                 <a:latin typeface="Arial" pitchFamily="34" charset="0"/>
                 <a:ea typeface="Arial" pitchFamily="34" charset="-122"/>
@@ -7205,7 +7205,7 @@
             <a:r>
               <a:rPr lang="ar-SA" altLang="en-US" sz="1100" dirty="0">
                 <a:solidFill>
-                  <a:srgbClr val="4A5C56"/>
+                  <a:srgbClr val="475569"/>
                 </a:solidFill>
                 <a:latin typeface="Arial" pitchFamily="34" charset="0"/>
                 <a:ea typeface="Arial" pitchFamily="34" charset="-122"/>
@@ -7256,11 +7256,11 @@
             <a:avLst/>
           </a:prstGeom>
           <a:solidFill>
-            <a:srgbClr val="1D6B58"/>
+            <a:srgbClr val="10B981"/>
           </a:solidFill>
           <a:ln w="12700">
             <a:solidFill>
-              <a:srgbClr val="1D6B58"/>
+              <a:srgbClr val="10B981"/>
             </a:solidFill>
             <a:prstDash val="solid"/>
           </a:ln>
@@ -7317,7 +7317,7 @@
             <a:r>
               <a:rPr lang="ar-SA" altLang="en-US" sz="1500" b="1" dirty="0">
                 <a:solidFill>
-                  <a:srgbClr val="12241F"/>
+                  <a:srgbClr val="0F172A"/>
                 </a:solidFill>
                 <a:latin typeface="Arial" pitchFamily="34" charset="0"/>
                 <a:ea typeface="Arial" pitchFamily="34" charset="-122"/>
@@ -7356,7 +7356,7 @@
             <a:r>
               <a:rPr lang="ar-SA" altLang="en-US" sz="1100" dirty="0">
                 <a:solidFill>
-                  <a:srgbClr val="4A5C56"/>
+                  <a:srgbClr val="475569"/>
                 </a:solidFill>
                 <a:latin typeface="Arial" pitchFamily="34" charset="0"/>
                 <a:ea typeface="Arial" pitchFamily="34" charset="-122"/>
@@ -7407,11 +7407,11 @@
             <a:avLst/>
           </a:prstGeom>
           <a:solidFill>
-            <a:srgbClr val="1D6B58"/>
+            <a:srgbClr val="10B981"/>
           </a:solidFill>
           <a:ln w="12700">
             <a:solidFill>
-              <a:srgbClr val="1D6B58"/>
+              <a:srgbClr val="10B981"/>
             </a:solidFill>
             <a:prstDash val="solid"/>
           </a:ln>
@@ -7468,7 +7468,7 @@
             <a:r>
               <a:rPr lang="ar-SA" altLang="en-US" sz="1500" b="1" dirty="0">
                 <a:solidFill>
-                  <a:srgbClr val="12241F"/>
+                  <a:srgbClr val="0F172A"/>
                 </a:solidFill>
                 <a:latin typeface="Arial" pitchFamily="34" charset="0"/>
                 <a:ea typeface="Arial" pitchFamily="34" charset="-122"/>
@@ -7507,7 +7507,7 @@
             <a:r>
               <a:rPr lang="ar-SA" altLang="en-US" sz="1100" dirty="0">
                 <a:solidFill>
-                  <a:srgbClr val="4A5C56"/>
+                  <a:srgbClr val="475569"/>
                 </a:solidFill>
                 <a:latin typeface="Arial" pitchFamily="34" charset="0"/>
                 <a:ea typeface="Arial" pitchFamily="34" charset="-122"/>
@@ -7558,11 +7558,11 @@
             <a:avLst/>
           </a:prstGeom>
           <a:solidFill>
-            <a:srgbClr val="1D6B58"/>
+            <a:srgbClr val="10B981"/>
           </a:solidFill>
           <a:ln w="12700">
             <a:solidFill>
-              <a:srgbClr val="1D6B58"/>
+              <a:srgbClr val="10B981"/>
             </a:solidFill>
             <a:prstDash val="solid"/>
           </a:ln>
@@ -7619,7 +7619,7 @@
             <a:r>
               <a:rPr lang="ar-SA" altLang="en-US" sz="1500" b="1" dirty="0">
                 <a:solidFill>
-                  <a:srgbClr val="12241F"/>
+                  <a:srgbClr val="0F172A"/>
                 </a:solidFill>
                 <a:latin typeface="Arial" pitchFamily="34" charset="0"/>
                 <a:ea typeface="Arial" pitchFamily="34" charset="-122"/>
@@ -7658,7 +7658,7 @@
             <a:r>
               <a:rPr lang="ar-SA" altLang="en-US" sz="1100" dirty="0">
                 <a:solidFill>
-                  <a:srgbClr val="4A5C56"/>
+                  <a:srgbClr val="475569"/>
                 </a:solidFill>
                 <a:latin typeface="Arial" pitchFamily="34" charset="0"/>
                 <a:ea typeface="Arial" pitchFamily="34" charset="-122"/>
@@ -7709,11 +7709,11 @@
             <a:avLst/>
           </a:prstGeom>
           <a:solidFill>
-            <a:srgbClr val="1D6B58"/>
+            <a:srgbClr val="10B981"/>
           </a:solidFill>
           <a:ln w="12700">
             <a:solidFill>
-              <a:srgbClr val="1D6B58"/>
+              <a:srgbClr val="10B981"/>
             </a:solidFill>
             <a:prstDash val="solid"/>
           </a:ln>
@@ -7770,7 +7770,7 @@
             <a:r>
               <a:rPr lang="ar-SA" altLang="en-US" sz="1500" b="1" dirty="0">
                 <a:solidFill>
-                  <a:srgbClr val="12241F"/>
+                  <a:srgbClr val="0F172A"/>
                 </a:solidFill>
                 <a:latin typeface="Arial" pitchFamily="34" charset="0"/>
                 <a:ea typeface="Arial" pitchFamily="34" charset="-122"/>
@@ -7809,7 +7809,7 @@
             <a:r>
               <a:rPr lang="ar-SA" altLang="en-US" sz="1100" dirty="0">
                 <a:solidFill>
-                  <a:srgbClr val="4A5C56"/>
+                  <a:srgbClr val="475569"/>
                 </a:solidFill>
                 <a:latin typeface="Arial" pitchFamily="34" charset="0"/>
                 <a:ea typeface="Arial" pitchFamily="34" charset="-122"/>
@@ -7860,11 +7860,11 @@
             <a:avLst/>
           </a:prstGeom>
           <a:solidFill>
-            <a:srgbClr val="1D6B58"/>
+            <a:srgbClr val="10B981"/>
           </a:solidFill>
           <a:ln w="12700">
             <a:solidFill>
-              <a:srgbClr val="1D6B58"/>
+              <a:srgbClr val="10B981"/>
             </a:solidFill>
             <a:prstDash val="solid"/>
           </a:ln>
@@ -7921,7 +7921,7 @@
             <a:r>
               <a:rPr lang="ar-SA" altLang="en-US" sz="1500" b="1" dirty="0">
                 <a:solidFill>
-                  <a:srgbClr val="12241F"/>
+                  <a:srgbClr val="0F172A"/>
                 </a:solidFill>
                 <a:latin typeface="Arial" pitchFamily="34" charset="0"/>
                 <a:ea typeface="Arial" pitchFamily="34" charset="-122"/>
@@ -7960,7 +7960,7 @@
             <a:r>
               <a:rPr lang="ar-SA" altLang="en-US" sz="1100" dirty="0">
                 <a:solidFill>
-                  <a:srgbClr val="4A5C56"/>
+                  <a:srgbClr val="475569"/>
                 </a:solidFill>
                 <a:latin typeface="Arial" pitchFamily="34" charset="0"/>
                 <a:ea typeface="Arial" pitchFamily="34" charset="-122"/>
@@ -8011,11 +8011,11 @@
             <a:avLst/>
           </a:prstGeom>
           <a:solidFill>
-            <a:srgbClr val="A8660F"/>
+            <a:srgbClr val="FACC15"/>
           </a:solidFill>
           <a:ln w="12700">
             <a:solidFill>
-              <a:srgbClr val="A8660F"/>
+              <a:srgbClr val="FACC15"/>
             </a:solidFill>
             <a:prstDash val="solid"/>
           </a:ln>
@@ -8072,7 +8072,7 @@
             <a:r>
               <a:rPr lang="ar-SA" altLang="en-US" sz="1500" b="1" dirty="0">
                 <a:solidFill>
-                  <a:srgbClr val="12241F"/>
+                  <a:srgbClr val="0F172A"/>
                 </a:solidFill>
                 <a:latin typeface="Arial" pitchFamily="34" charset="0"/>
                 <a:ea typeface="Arial" pitchFamily="34" charset="-122"/>
@@ -8111,7 +8111,7 @@
             <a:r>
               <a:rPr lang="ar-SA" altLang="en-US" sz="1100" dirty="0">
                 <a:solidFill>
-                  <a:srgbClr val="4A5C56"/>
+                  <a:srgbClr val="475569"/>
                 </a:solidFill>
                 <a:latin typeface="Arial" pitchFamily="34" charset="0"/>
                 <a:ea typeface="Arial" pitchFamily="34" charset="-122"/>
@@ -8144,7 +8144,7 @@
           </a:solidFill>
           <a:ln w="12700">
             <a:solidFill>
-              <a:srgbClr val="D9E1DC"/>
+              <a:srgbClr val="E2E8F0"/>
             </a:solidFill>
             <a:prstDash val="solid"/>
           </a:ln>
@@ -8177,7 +8177,7 @@
             <a:r>
               <a:rPr lang="ar-SA" altLang="en-US" sz="1250" b="1" dirty="0">
                 <a:solidFill>
-                  <a:srgbClr val="1D6B58"/>
+                  <a:srgbClr val="047857"/>
                 </a:solidFill>
                 <a:latin typeface="Arial" pitchFamily="34" charset="0"/>
                 <a:ea typeface="Arial" pitchFamily="34" charset="-122"/>
@@ -8216,7 +8216,7 @@
             <a:r>
               <a:rPr lang="ar-SA" altLang="en-US" sz="900" dirty="0">
                 <a:solidFill>
-                  <a:srgbClr val="7A8A84"/>
+                  <a:srgbClr val="64748B"/>
                 </a:solidFill>
                 <a:latin typeface="Arial" pitchFamily="34" charset="0"/>
                 <a:ea typeface="Arial" pitchFamily="34" charset="-122"/>
@@ -8255,7 +8255,7 @@
             <a:r>
               <a:rPr lang="en-US" sz="900" dirty="0">
                 <a:solidFill>
-                  <a:srgbClr val="7A8A84"/>
+                  <a:srgbClr val="64748B"/>
                 </a:solidFill>
                 <a:latin typeface="Arial" pitchFamily="34" charset="0"/>
                 <a:ea typeface="Arial" pitchFamily="34" charset="-122"/>
@@ -8326,7 +8326,7 @@
             <a:r>
               <a:rPr lang="ar-SA" altLang="en-US" sz="3000" b="1" dirty="0">
                 <a:solidFill>
-                  <a:srgbClr val="12241F"/>
+                  <a:srgbClr val="0F172A"/>
                 </a:solidFill>
                 <a:latin typeface="Arial" pitchFamily="34" charset="0"/>
                 <a:ea typeface="Arial" pitchFamily="34" charset="-122"/>
@@ -8365,7 +8365,7 @@
             <a:r>
               <a:rPr lang="ar-SA" altLang="en-US" sz="1400" dirty="0">
                 <a:solidFill>
-                  <a:srgbClr val="4A5C56"/>
+                  <a:srgbClr val="475569"/>
                 </a:solidFill>
                 <a:latin typeface="Arial" pitchFamily="34" charset="0"/>
                 <a:ea typeface="Arial" pitchFamily="34" charset="-122"/>
@@ -8398,7 +8398,7 @@
           </a:solidFill>
           <a:ln w="9525">
             <a:solidFill>
-              <a:srgbClr val="D9E1DC"/>
+              <a:srgbClr val="E2E8F0"/>
             </a:solidFill>
             <a:prstDash val="solid"/>
           </a:ln>
@@ -8428,11 +8428,11 @@
             </a:avLst>
           </a:prstGeom>
           <a:solidFill>
-            <a:srgbClr val="F8EAD3"/>
+            <a:srgbClr val="FEF9C3"/>
           </a:solidFill>
           <a:ln w="12700">
             <a:solidFill>
-              <a:srgbClr val="F8EAD3"/>
+              <a:srgbClr val="FEF9C3"/>
             </a:solidFill>
             <a:prstDash val="solid"/>
           </a:ln>
@@ -8465,7 +8465,7 @@
             <a:r>
               <a:rPr lang="ar-SA" altLang="en-US" sz="1200" b="1" dirty="0">
                 <a:solidFill>
-                  <a:srgbClr val="A8660F"/>
+                  <a:srgbClr val="A16207"/>
                 </a:solidFill>
                 <a:latin typeface="Arial" pitchFamily="34" charset="0"/>
                 <a:ea typeface="Arial" pitchFamily="34" charset="-122"/>
@@ -8504,7 +8504,7 @@
             <a:r>
               <a:rPr lang="ar-SA" altLang="en-US" sz="1800" b="1" dirty="0">
                 <a:solidFill>
-                  <a:srgbClr val="12241F"/>
+                  <a:srgbClr val="0F172A"/>
                 </a:solidFill>
                 <a:latin typeface="Arial" pitchFamily="34" charset="0"/>
                 <a:ea typeface="Arial" pitchFamily="34" charset="-122"/>
@@ -8543,7 +8543,7 @@
             <a:r>
               <a:rPr lang="ar-SA" altLang="en-US" sz="1250" dirty="0">
                 <a:solidFill>
-                  <a:srgbClr val="4A5C56"/>
+                  <a:srgbClr val="475569"/>
                 </a:solidFill>
                 <a:latin typeface="Arial" pitchFamily="34" charset="0"/>
                 <a:ea typeface="Arial" pitchFamily="34" charset="-122"/>
@@ -8582,7 +8582,7 @@
             <a:r>
               <a:rPr lang="ar-SA" altLang="en-US" sz="1250" dirty="0">
                 <a:solidFill>
-                  <a:srgbClr val="4A5C56"/>
+                  <a:srgbClr val="475569"/>
                 </a:solidFill>
                 <a:latin typeface="Arial" pitchFamily="34" charset="0"/>
                 <a:ea typeface="Arial" pitchFamily="34" charset="-122"/>
@@ -8621,7 +8621,7 @@
             <a:r>
               <a:rPr lang="ar-SA" altLang="en-US" sz="1400" b="1" dirty="0">
                 <a:solidFill>
-                  <a:srgbClr val="1D6B58"/>
+                  <a:srgbClr val="047857"/>
                 </a:solidFill>
                 <a:latin typeface="Arial" pitchFamily="34" charset="0"/>
                 <a:ea typeface="Arial" pitchFamily="34" charset="-122"/>
@@ -8650,11 +8650,11 @@
             </a:avLst>
           </a:prstGeom>
           <a:solidFill>
-            <a:srgbClr val="1D6B58"/>
+            <a:srgbClr val="10B981"/>
           </a:solidFill>
           <a:ln w="12700">
             <a:solidFill>
-              <a:srgbClr val="1D6B58"/>
+              <a:srgbClr val="10B981"/>
             </a:solidFill>
             <a:prstDash val="solid"/>
           </a:ln>
@@ -8687,7 +8687,7 @@
             <a:r>
               <a:rPr lang="ar-SA" altLang="en-US" sz="1300" b="1" dirty="0">
                 <a:solidFill>
-                  <a:srgbClr val="FFFFFF"/>
+                  <a:srgbClr val="0F172A"/>
                 </a:solidFill>
                 <a:latin typeface="Arial" pitchFamily="34" charset="0"/>
                 <a:ea typeface="Arial" pitchFamily="34" charset="-122"/>
@@ -8716,11 +8716,11 @@
             </a:avLst>
           </a:prstGeom>
           <a:solidFill>
-            <a:srgbClr val="F4F7F5"/>
+            <a:srgbClr val="F8FAFC"/>
           </a:solidFill>
           <a:ln w="9525">
             <a:solidFill>
-              <a:srgbClr val="D9E1DC"/>
+              <a:srgbClr val="E2E8F0"/>
             </a:solidFill>
             <a:prstDash val="solid"/>
           </a:ln>
@@ -8760,7 +8760,7 @@
             <a:r>
               <a:rPr lang="ar-SA" altLang="en-US" sz="1300" b="1" dirty="0">
                 <a:solidFill>
-                  <a:srgbClr val="7A8A84"/>
+                  <a:srgbClr val="64748B"/>
                 </a:solidFill>
                 <a:latin typeface="Arial" pitchFamily="34" charset="0"/>
                 <a:ea typeface="Arial" pitchFamily="34" charset="-122"/>
@@ -8799,7 +8799,7 @@
             <a:r>
               <a:rPr lang="ar-SA" altLang="en-US" sz="3600" b="1" dirty="0">
                 <a:solidFill>
-                  <a:srgbClr val="23794A"/>
+                  <a:srgbClr val="15803D"/>
                 </a:solidFill>
                 <a:latin typeface="Arial" pitchFamily="34" charset="0"/>
                 <a:ea typeface="Arial" pitchFamily="34" charset="-122"/>
@@ -8838,7 +8838,7 @@
             <a:r>
               <a:rPr lang="ar-SA" altLang="en-US" sz="1100" dirty="0">
                 <a:solidFill>
-                  <a:srgbClr val="4A5C56"/>
+                  <a:srgbClr val="475569"/>
                 </a:solidFill>
                 <a:latin typeface="Arial" pitchFamily="34" charset="0"/>
                 <a:ea typeface="Arial" pitchFamily="34" charset="-122"/>
@@ -8877,7 +8877,7 @@
             <a:r>
               <a:rPr lang="ar-SA" altLang="en-US" sz="2600" b="1" dirty="0">
                 <a:solidFill>
-                  <a:srgbClr val="7A8A84"/>
+                  <a:srgbClr val="64748B"/>
                 </a:solidFill>
                 <a:latin typeface="Arial" pitchFamily="34" charset="0"/>
                 <a:ea typeface="Arial" pitchFamily="34" charset="-122"/>
@@ -8916,7 +8916,7 @@
             <a:r>
               <a:rPr lang="ar-SA" altLang="en-US" sz="1100" dirty="0">
                 <a:solidFill>
-                  <a:srgbClr val="4A5C56"/>
+                  <a:srgbClr val="475569"/>
                 </a:solidFill>
                 <a:latin typeface="Arial" pitchFamily="34" charset="0"/>
                 <a:ea typeface="Arial" pitchFamily="34" charset="-122"/>
@@ -8955,7 +8955,7 @@
             <a:r>
               <a:rPr lang="ar-SA" altLang="en-US" sz="1400" b="1" dirty="0">
                 <a:solidFill>
-                  <a:srgbClr val="23794A"/>
+                  <a:srgbClr val="15803D"/>
                 </a:solidFill>
                 <a:latin typeface="Arial" pitchFamily="34" charset="0"/>
                 <a:ea typeface="Arial" pitchFamily="34" charset="-122"/>
@@ -8994,7 +8994,7 @@
             <a:r>
               <a:rPr lang="ar-SA" altLang="en-US" sz="900" dirty="0">
                 <a:solidFill>
-                  <a:srgbClr val="7A8A84"/>
+                  <a:srgbClr val="64748B"/>
                 </a:solidFill>
                 <a:latin typeface="Arial" pitchFamily="34" charset="0"/>
                 <a:ea typeface="Arial" pitchFamily="34" charset="-122"/>
@@ -9033,7 +9033,7 @@
             <a:r>
               <a:rPr lang="en-US" sz="900" dirty="0">
                 <a:solidFill>
-                  <a:srgbClr val="7A8A84"/>
+                  <a:srgbClr val="64748B"/>
                 </a:solidFill>
                 <a:latin typeface="Arial" pitchFamily="34" charset="0"/>
                 <a:ea typeface="Arial" pitchFamily="34" charset="-122"/>
@@ -9104,7 +9104,7 @@
             <a:r>
               <a:rPr lang="ar-SA" altLang="en-US" sz="3000" b="1" dirty="0">
                 <a:solidFill>
-                  <a:srgbClr val="12241F"/>
+                  <a:srgbClr val="0F172A"/>
                 </a:solidFill>
                 <a:latin typeface="Arial" pitchFamily="34" charset="0"/>
                 <a:ea typeface="Arial" pitchFamily="34" charset="-122"/>
@@ -9143,7 +9143,7 @@
             <a:r>
               <a:rPr lang="ar-SA" altLang="en-US" sz="1400" dirty="0">
                 <a:solidFill>
-                  <a:srgbClr val="4A5C56"/>
+                  <a:srgbClr val="475569"/>
                 </a:solidFill>
                 <a:latin typeface="Arial" pitchFamily="34" charset="0"/>
                 <a:ea typeface="Arial" pitchFamily="34" charset="-122"/>
@@ -9172,11 +9172,11 @@
             </a:avLst>
           </a:prstGeom>
           <a:solidFill>
-            <a:srgbClr val="F4F7F5"/>
+            <a:srgbClr val="F8FAFC"/>
           </a:solidFill>
           <a:ln w="9525">
             <a:solidFill>
-              <a:srgbClr val="D9E1DC"/>
+              <a:srgbClr val="E2E8F0"/>
             </a:solidFill>
             <a:prstDash val="solid"/>
           </a:ln>
@@ -9204,11 +9204,11 @@
             <a:avLst/>
           </a:prstGeom>
           <a:solidFill>
-            <a:srgbClr val="DCEDE6"/>
+            <a:srgbClr val="D1FAE5"/>
           </a:solidFill>
           <a:ln w="12700">
             <a:solidFill>
-              <a:srgbClr val="DCEDE6"/>
+              <a:srgbClr val="D1FAE5"/>
             </a:solidFill>
             <a:prstDash val="solid"/>
           </a:ln>
@@ -9265,7 +9265,7 @@
             <a:r>
               <a:rPr lang="ar-SA" altLang="en-US" sz="1500" b="1" dirty="0">
                 <a:solidFill>
-                  <a:srgbClr val="12241F"/>
+                  <a:srgbClr val="0F172A"/>
                 </a:solidFill>
                 <a:latin typeface="Arial" pitchFamily="34" charset="0"/>
                 <a:ea typeface="Arial" pitchFamily="34" charset="-122"/>
@@ -9304,7 +9304,7 @@
             <a:r>
               <a:rPr lang="ar-SA" altLang="en-US" sz="1150" dirty="0">
                 <a:solidFill>
-                  <a:srgbClr val="4A5C56"/>
+                  <a:srgbClr val="475569"/>
                 </a:solidFill>
                 <a:latin typeface="Arial" pitchFamily="34" charset="0"/>
                 <a:ea typeface="Arial" pitchFamily="34" charset="-122"/>
@@ -9333,11 +9333,11 @@
             </a:avLst>
           </a:prstGeom>
           <a:solidFill>
-            <a:srgbClr val="F4F7F5"/>
+            <a:srgbClr val="F8FAFC"/>
           </a:solidFill>
           <a:ln w="9525">
             <a:solidFill>
-              <a:srgbClr val="D9E1DC"/>
+              <a:srgbClr val="E2E8F0"/>
             </a:solidFill>
             <a:prstDash val="solid"/>
           </a:ln>
@@ -9365,11 +9365,11 @@
             <a:avLst/>
           </a:prstGeom>
           <a:solidFill>
-            <a:srgbClr val="DCEDE6"/>
+            <a:srgbClr val="D1FAE5"/>
           </a:solidFill>
           <a:ln w="12700">
             <a:solidFill>
-              <a:srgbClr val="DCEDE6"/>
+              <a:srgbClr val="D1FAE5"/>
             </a:solidFill>
             <a:prstDash val="solid"/>
           </a:ln>
@@ -9426,7 +9426,7 @@
             <a:r>
               <a:rPr lang="ar-SA" altLang="en-US" sz="1500" b="1" dirty="0">
                 <a:solidFill>
-                  <a:srgbClr val="12241F"/>
+                  <a:srgbClr val="0F172A"/>
                 </a:solidFill>
                 <a:latin typeface="Arial" pitchFamily="34" charset="0"/>
                 <a:ea typeface="Arial" pitchFamily="34" charset="-122"/>
@@ -9465,7 +9465,7 @@
             <a:r>
               <a:rPr lang="ar-SA" altLang="en-US" sz="1150" dirty="0">
                 <a:solidFill>
-                  <a:srgbClr val="4A5C56"/>
+                  <a:srgbClr val="475569"/>
                 </a:solidFill>
                 <a:latin typeface="Arial" pitchFamily="34" charset="0"/>
                 <a:ea typeface="Arial" pitchFamily="34" charset="-122"/>
@@ -9494,11 +9494,11 @@
             </a:avLst>
           </a:prstGeom>
           <a:solidFill>
-            <a:srgbClr val="F4F7F5"/>
+            <a:srgbClr val="F8FAFC"/>
           </a:solidFill>
           <a:ln w="9525">
             <a:solidFill>
-              <a:srgbClr val="D9E1DC"/>
+              <a:srgbClr val="E2E8F0"/>
             </a:solidFill>
             <a:prstDash val="solid"/>
           </a:ln>
@@ -9526,11 +9526,11 @@
             <a:avLst/>
           </a:prstGeom>
           <a:solidFill>
-            <a:srgbClr val="DCEDE6"/>
+            <a:srgbClr val="D1FAE5"/>
           </a:solidFill>
           <a:ln w="12700">
             <a:solidFill>
-              <a:srgbClr val="DCEDE6"/>
+              <a:srgbClr val="D1FAE5"/>
             </a:solidFill>
             <a:prstDash val="solid"/>
           </a:ln>
@@ -9587,7 +9587,7 @@
             <a:r>
               <a:rPr lang="ar-SA" altLang="en-US" sz="1500" b="1" dirty="0">
                 <a:solidFill>
-                  <a:srgbClr val="12241F"/>
+                  <a:srgbClr val="0F172A"/>
                 </a:solidFill>
                 <a:latin typeface="Arial" pitchFamily="34" charset="0"/>
                 <a:ea typeface="Arial" pitchFamily="34" charset="-122"/>
@@ -9626,7 +9626,7 @@
             <a:r>
               <a:rPr lang="ar-SA" altLang="en-US" sz="1150" dirty="0">
                 <a:solidFill>
-                  <a:srgbClr val="4A5C56"/>
+                  <a:srgbClr val="475569"/>
                 </a:solidFill>
                 <a:latin typeface="Arial" pitchFamily="34" charset="0"/>
                 <a:ea typeface="Arial" pitchFamily="34" charset="-122"/>
@@ -9655,11 +9655,11 @@
             </a:avLst>
           </a:prstGeom>
           <a:solidFill>
-            <a:srgbClr val="F4F7F5"/>
+            <a:srgbClr val="F8FAFC"/>
           </a:solidFill>
           <a:ln w="9525">
             <a:solidFill>
-              <a:srgbClr val="D9E1DC"/>
+              <a:srgbClr val="E2E8F0"/>
             </a:solidFill>
             <a:prstDash val="solid"/>
           </a:ln>
@@ -9687,11 +9687,11 @@
             <a:avLst/>
           </a:prstGeom>
           <a:solidFill>
-            <a:srgbClr val="DCEDE6"/>
+            <a:srgbClr val="D1FAE5"/>
           </a:solidFill>
           <a:ln w="12700">
             <a:solidFill>
-              <a:srgbClr val="DCEDE6"/>
+              <a:srgbClr val="D1FAE5"/>
             </a:solidFill>
             <a:prstDash val="solid"/>
           </a:ln>
@@ -9748,7 +9748,7 @@
             <a:r>
               <a:rPr lang="ar-SA" altLang="en-US" sz="1500" b="1" dirty="0">
                 <a:solidFill>
-                  <a:srgbClr val="12241F"/>
+                  <a:srgbClr val="0F172A"/>
                 </a:solidFill>
                 <a:latin typeface="Arial" pitchFamily="34" charset="0"/>
                 <a:ea typeface="Arial" pitchFamily="34" charset="-122"/>
@@ -9787,7 +9787,7 @@
             <a:r>
               <a:rPr lang="ar-SA" altLang="en-US" sz="1150" dirty="0">
                 <a:solidFill>
-                  <a:srgbClr val="4A5C56"/>
+                  <a:srgbClr val="475569"/>
                 </a:solidFill>
                 <a:latin typeface="Arial" pitchFamily="34" charset="0"/>
                 <a:ea typeface="Arial" pitchFamily="34" charset="-122"/>
@@ -9816,11 +9816,11 @@
             </a:avLst>
           </a:prstGeom>
           <a:solidFill>
-            <a:srgbClr val="F4F7F5"/>
+            <a:srgbClr val="F8FAFC"/>
           </a:solidFill>
           <a:ln w="9525">
             <a:solidFill>
-              <a:srgbClr val="D9E1DC"/>
+              <a:srgbClr val="E2E8F0"/>
             </a:solidFill>
             <a:prstDash val="solid"/>
           </a:ln>
@@ -9848,11 +9848,11 @@
             <a:avLst/>
           </a:prstGeom>
           <a:solidFill>
-            <a:srgbClr val="DCEDE6"/>
+            <a:srgbClr val="D1FAE5"/>
           </a:solidFill>
           <a:ln w="12700">
             <a:solidFill>
-              <a:srgbClr val="DCEDE6"/>
+              <a:srgbClr val="D1FAE5"/>
             </a:solidFill>
             <a:prstDash val="solid"/>
           </a:ln>
@@ -9909,7 +9909,7 @@
             <a:r>
               <a:rPr lang="ar-SA" altLang="en-US" sz="1500" b="1" dirty="0">
                 <a:solidFill>
-                  <a:srgbClr val="12241F"/>
+                  <a:srgbClr val="0F172A"/>
                 </a:solidFill>
                 <a:latin typeface="Arial" pitchFamily="34" charset="0"/>
                 <a:ea typeface="Arial" pitchFamily="34" charset="-122"/>
@@ -9948,7 +9948,7 @@
             <a:r>
               <a:rPr lang="ar-SA" altLang="en-US" sz="1150" dirty="0">
                 <a:solidFill>
-                  <a:srgbClr val="4A5C56"/>
+                  <a:srgbClr val="475569"/>
                 </a:solidFill>
                 <a:latin typeface="Arial" pitchFamily="34" charset="0"/>
                 <a:ea typeface="Arial" pitchFamily="34" charset="-122"/>
@@ -9977,11 +9977,11 @@
             </a:avLst>
           </a:prstGeom>
           <a:solidFill>
-            <a:srgbClr val="F4F7F5"/>
+            <a:srgbClr val="F8FAFC"/>
           </a:solidFill>
           <a:ln w="9525">
             <a:solidFill>
-              <a:srgbClr val="D9E1DC"/>
+              <a:srgbClr val="E2E8F0"/>
             </a:solidFill>
             <a:prstDash val="solid"/>
           </a:ln>
@@ -10009,11 +10009,11 @@
             <a:avLst/>
           </a:prstGeom>
           <a:solidFill>
-            <a:srgbClr val="DCEDE6"/>
+            <a:srgbClr val="D1FAE5"/>
           </a:solidFill>
           <a:ln w="12700">
             <a:solidFill>
-              <a:srgbClr val="DCEDE6"/>
+              <a:srgbClr val="D1FAE5"/>
             </a:solidFill>
             <a:prstDash val="solid"/>
           </a:ln>
@@ -10070,7 +10070,7 @@
             <a:r>
               <a:rPr lang="ar-SA" altLang="en-US" sz="1500" b="1" dirty="0">
                 <a:solidFill>
-                  <a:srgbClr val="12241F"/>
+                  <a:srgbClr val="0F172A"/>
                 </a:solidFill>
                 <a:latin typeface="Arial" pitchFamily="34" charset="0"/>
                 <a:ea typeface="Arial" pitchFamily="34" charset="-122"/>
@@ -10109,7 +10109,7 @@
             <a:r>
               <a:rPr lang="ar-SA" altLang="en-US" sz="1150" dirty="0">
                 <a:solidFill>
-                  <a:srgbClr val="4A5C56"/>
+                  <a:srgbClr val="475569"/>
                 </a:solidFill>
                 <a:latin typeface="Arial" pitchFamily="34" charset="0"/>
                 <a:ea typeface="Arial" pitchFamily="34" charset="-122"/>
@@ -10148,7 +10148,7 @@
             <a:r>
               <a:rPr lang="ar-SA" altLang="en-US" sz="900" dirty="0">
                 <a:solidFill>
-                  <a:srgbClr val="7A8A84"/>
+                  <a:srgbClr val="64748B"/>
                 </a:solidFill>
                 <a:latin typeface="Arial" pitchFamily="34" charset="0"/>
                 <a:ea typeface="Arial" pitchFamily="34" charset="-122"/>
@@ -10187,7 +10187,7 @@
             <a:r>
               <a:rPr lang="en-US" sz="900" dirty="0">
                 <a:solidFill>
-                  <a:srgbClr val="7A8A84"/>
+                  <a:srgbClr val="64748B"/>
                 </a:solidFill>
                 <a:latin typeface="Arial" pitchFamily="34" charset="0"/>
                 <a:ea typeface="Arial" pitchFamily="34" charset="-122"/>
@@ -10258,7 +10258,7 @@
             <a:r>
               <a:rPr lang="ar-SA" altLang="en-US" sz="3000" b="1" dirty="0">
                 <a:solidFill>
-                  <a:srgbClr val="12241F"/>
+                  <a:srgbClr val="0F172A"/>
                 </a:solidFill>
                 <a:latin typeface="Arial" pitchFamily="34" charset="0"/>
                 <a:ea typeface="Arial" pitchFamily="34" charset="-122"/>
@@ -10297,7 +10297,7 @@
             <a:r>
               <a:rPr lang="ar-SA" altLang="en-US" sz="1400" dirty="0">
                 <a:solidFill>
-                  <a:srgbClr val="4A5C56"/>
+                  <a:srgbClr val="475569"/>
                 </a:solidFill>
                 <a:latin typeface="Arial" pitchFamily="34" charset="0"/>
                 <a:ea typeface="Arial" pitchFamily="34" charset="-122"/>
@@ -10326,11 +10326,11 @@
             </a:avLst>
           </a:prstGeom>
           <a:solidFill>
-            <a:srgbClr val="F4F7F5"/>
+            <a:srgbClr val="F8FAFC"/>
           </a:solidFill>
           <a:ln w="9525">
             <a:solidFill>
-              <a:srgbClr val="D9E1DC"/>
+              <a:srgbClr val="E2E8F0"/>
             </a:solidFill>
             <a:prstDash val="solid"/>
           </a:ln>
@@ -10370,7 +10370,7 @@
             <a:r>
               <a:rPr lang="ar-SA" altLang="en-US" sz="3000" b="1" dirty="0">
                 <a:solidFill>
-                  <a:srgbClr val="1D6B58"/>
+                  <a:srgbClr val="047857"/>
                 </a:solidFill>
                 <a:latin typeface="Arial" pitchFamily="34" charset="0"/>
                 <a:ea typeface="Arial" pitchFamily="34" charset="-122"/>
@@ -10409,7 +10409,7 @@
             <a:r>
               <a:rPr lang="ar-SA" altLang="en-US" sz="1200" dirty="0">
                 <a:solidFill>
-                  <a:srgbClr val="4A5C56"/>
+                  <a:srgbClr val="475569"/>
                 </a:solidFill>
                 <a:latin typeface="Arial" pitchFamily="34" charset="0"/>
                 <a:ea typeface="Arial" pitchFamily="34" charset="-122"/>
@@ -10438,11 +10438,11 @@
             </a:avLst>
           </a:prstGeom>
           <a:solidFill>
-            <a:srgbClr val="F4F7F5"/>
+            <a:srgbClr val="F8FAFC"/>
           </a:solidFill>
           <a:ln w="9525">
             <a:solidFill>
-              <a:srgbClr val="D9E1DC"/>
+              <a:srgbClr val="E2E8F0"/>
             </a:solidFill>
             <a:prstDash val="solid"/>
           </a:ln>
@@ -10482,7 +10482,7 @@
             <a:r>
               <a:rPr lang="ar-SA" altLang="en-US" sz="3000" b="1" dirty="0">
                 <a:solidFill>
-                  <a:srgbClr val="1D6B58"/>
+                  <a:srgbClr val="047857"/>
                 </a:solidFill>
                 <a:latin typeface="Arial" pitchFamily="34" charset="0"/>
                 <a:ea typeface="Arial" pitchFamily="34" charset="-122"/>
@@ -10521,7 +10521,7 @@
             <a:r>
               <a:rPr lang="ar-SA" altLang="en-US" sz="1200" dirty="0">
                 <a:solidFill>
-                  <a:srgbClr val="4A5C56"/>
+                  <a:srgbClr val="475569"/>
                 </a:solidFill>
                 <a:latin typeface="Arial" pitchFamily="34" charset="0"/>
                 <a:ea typeface="Arial" pitchFamily="34" charset="-122"/>
@@ -10550,11 +10550,11 @@
             </a:avLst>
           </a:prstGeom>
           <a:solidFill>
-            <a:srgbClr val="F4F7F5"/>
+            <a:srgbClr val="F8FAFC"/>
           </a:solidFill>
           <a:ln w="9525">
             <a:solidFill>
-              <a:srgbClr val="D9E1DC"/>
+              <a:srgbClr val="E2E8F0"/>
             </a:solidFill>
             <a:prstDash val="solid"/>
           </a:ln>
@@ -10594,7 +10594,7 @@
             <a:r>
               <a:rPr lang="ar-SA" altLang="en-US" sz="3000" b="1" dirty="0">
                 <a:solidFill>
-                  <a:srgbClr val="1D6B58"/>
+                  <a:srgbClr val="047857"/>
                 </a:solidFill>
                 <a:latin typeface="Arial" pitchFamily="34" charset="0"/>
                 <a:ea typeface="Arial" pitchFamily="34" charset="-122"/>
@@ -10633,7 +10633,7 @@
             <a:r>
               <a:rPr lang="ar-SA" altLang="en-US" sz="1200" dirty="0">
                 <a:solidFill>
-                  <a:srgbClr val="4A5C56"/>
+                  <a:srgbClr val="475569"/>
                 </a:solidFill>
                 <a:latin typeface="Arial" pitchFamily="34" charset="0"/>
                 <a:ea typeface="Arial" pitchFamily="34" charset="-122"/>
@@ -10672,7 +10672,7 @@
             <a:r>
               <a:rPr lang="ar-SA" altLang="en-US" sz="1400" b="1" dirty="0">
                 <a:solidFill>
-                  <a:srgbClr val="12241F"/>
+                  <a:srgbClr val="0F172A"/>
                 </a:solidFill>
                 <a:latin typeface="Arial" pitchFamily="34" charset="0"/>
                 <a:ea typeface="Arial" pitchFamily="34" charset="-122"/>
@@ -10711,7 +10711,7 @@
             <a:r>
               <a:rPr lang="ar-SA" altLang="en-US" sz="1250" dirty="0">
                 <a:solidFill>
-                  <a:srgbClr val="4A5C56"/>
+                  <a:srgbClr val="475569"/>
                 </a:solidFill>
                 <a:latin typeface="Arial" pitchFamily="34" charset="0"/>
                 <a:ea typeface="Arial" pitchFamily="34" charset="-122"/>
@@ -10750,7 +10750,7 @@
             <a:r>
               <a:rPr lang="ar-SA" altLang="en-US" sz="900" dirty="0">
                 <a:solidFill>
-                  <a:srgbClr val="7A8A84"/>
+                  <a:srgbClr val="64748B"/>
                 </a:solidFill>
                 <a:latin typeface="Arial" pitchFamily="34" charset="0"/>
                 <a:ea typeface="Arial" pitchFamily="34" charset="-122"/>
@@ -10789,7 +10789,7 @@
             <a:r>
               <a:rPr lang="ar-SA" altLang="en-US" sz="900" dirty="0">
                 <a:solidFill>
-                  <a:srgbClr val="7A8A84"/>
+                  <a:srgbClr val="64748B"/>
                 </a:solidFill>
                 <a:latin typeface="Arial" pitchFamily="34" charset="0"/>
                 <a:ea typeface="Arial" pitchFamily="34" charset="-122"/>
@@ -10828,7 +10828,7 @@
             <a:r>
               <a:rPr lang="en-US" sz="900" dirty="0">
                 <a:solidFill>
-                  <a:srgbClr val="7A8A84"/>
+                  <a:srgbClr val="64748B"/>
                 </a:solidFill>
                 <a:latin typeface="Arial" pitchFamily="34" charset="0"/>
                 <a:ea typeface="Arial" pitchFamily="34" charset="-122"/>
@@ -10854,7 +10854,7 @@
     <p:bg>
       <p:bgPr>
         <a:solidFill>
-          <a:srgbClr val="F4F7F5"/>
+          <a:srgbClr val="F8FAFC"/>
         </a:solidFill>
       </p:bgPr>
     </p:bg>
@@ -10899,7 +10899,7 @@
             <a:r>
               <a:rPr lang="ar-SA" altLang="en-US" sz="3000" b="1" dirty="0">
                 <a:solidFill>
-                  <a:srgbClr val="12241F"/>
+                  <a:srgbClr val="0F172A"/>
                 </a:solidFill>
                 <a:latin typeface="Arial" pitchFamily="34" charset="0"/>
                 <a:ea typeface="Arial" pitchFamily="34" charset="-122"/>
@@ -10938,7 +10938,7 @@
             <a:r>
               <a:rPr lang="ar-SA" altLang="en-US" sz="1400" dirty="0">
                 <a:solidFill>
-                  <a:srgbClr val="4A5C56"/>
+                  <a:srgbClr val="475569"/>
                 </a:solidFill>
                 <a:latin typeface="Arial" pitchFamily="34" charset="0"/>
                 <a:ea typeface="Arial" pitchFamily="34" charset="-122"/>
@@ -10971,7 +10971,7 @@
           </a:solidFill>
           <a:ln w="9525">
             <a:solidFill>
-              <a:srgbClr val="D9E1DC"/>
+              <a:srgbClr val="E2E8F0"/>
             </a:solidFill>
             <a:prstDash val="solid"/>
           </a:ln>
@@ -10999,11 +10999,11 @@
             <a:avLst/>
           </a:prstGeom>
           <a:solidFill>
-            <a:srgbClr val="DCEDE6"/>
+            <a:srgbClr val="D1FAE5"/>
           </a:solidFill>
           <a:ln w="12700">
             <a:solidFill>
-              <a:srgbClr val="DCEDE6"/>
+              <a:srgbClr val="D1FAE5"/>
             </a:solidFill>
             <a:prstDash val="solid"/>
           </a:ln>
@@ -11060,7 +11060,7 @@
             <a:r>
               <a:rPr lang="ar-SA" altLang="en-US" sz="1600" b="1" dirty="0">
                 <a:solidFill>
-                  <a:srgbClr val="12241F"/>
+                  <a:srgbClr val="0F172A"/>
                 </a:solidFill>
                 <a:latin typeface="Arial" pitchFamily="34" charset="0"/>
                 <a:ea typeface="Arial" pitchFamily="34" charset="-122"/>
@@ -11099,7 +11099,7 @@
             <a:r>
               <a:rPr lang="ar-SA" altLang="en-US" sz="1150" dirty="0">
                 <a:solidFill>
-                  <a:srgbClr val="4A5C56"/>
+                  <a:srgbClr val="475569"/>
                 </a:solidFill>
                 <a:latin typeface="Arial" pitchFamily="34" charset="0"/>
                 <a:ea typeface="Arial" pitchFamily="34" charset="-122"/>
@@ -11132,7 +11132,7 @@
           </a:solidFill>
           <a:ln w="9525">
             <a:solidFill>
-              <a:srgbClr val="D9E1DC"/>
+              <a:srgbClr val="E2E8F0"/>
             </a:solidFill>
             <a:prstDash val="solid"/>
           </a:ln>
@@ -11160,11 +11160,11 @@
             <a:avLst/>
           </a:prstGeom>
           <a:solidFill>
-            <a:srgbClr val="DCEDE6"/>
+            <a:srgbClr val="D1FAE5"/>
           </a:solidFill>
           <a:ln w="12700">
             <a:solidFill>
-              <a:srgbClr val="DCEDE6"/>
+              <a:srgbClr val="D1FAE5"/>
             </a:solidFill>
             <a:prstDash val="solid"/>
           </a:ln>
@@ -11221,7 +11221,7 @@
             <a:r>
               <a:rPr lang="ar-SA" altLang="en-US" sz="1600" b="1" dirty="0">
                 <a:solidFill>
-                  <a:srgbClr val="12241F"/>
+                  <a:srgbClr val="0F172A"/>
                 </a:solidFill>
                 <a:latin typeface="Arial" pitchFamily="34" charset="0"/>
                 <a:ea typeface="Arial" pitchFamily="34" charset="-122"/>
@@ -11260,7 +11260,7 @@
             <a:r>
               <a:rPr lang="ar-SA" altLang="en-US" sz="1150" dirty="0">
                 <a:solidFill>
-                  <a:srgbClr val="4A5C56"/>
+                  <a:srgbClr val="475569"/>
                 </a:solidFill>
                 <a:latin typeface="Arial" pitchFamily="34" charset="0"/>
                 <a:ea typeface="Arial" pitchFamily="34" charset="-122"/>
@@ -11293,7 +11293,7 @@
           </a:solidFill>
           <a:ln w="9525">
             <a:solidFill>
-              <a:srgbClr val="D9E1DC"/>
+              <a:srgbClr val="E2E8F0"/>
             </a:solidFill>
             <a:prstDash val="solid"/>
           </a:ln>
@@ -11321,11 +11321,11 @@
             <a:avLst/>
           </a:prstGeom>
           <a:solidFill>
-            <a:srgbClr val="DCEDE6"/>
+            <a:srgbClr val="D1FAE5"/>
           </a:solidFill>
           <a:ln w="12700">
             <a:solidFill>
-              <a:srgbClr val="DCEDE6"/>
+              <a:srgbClr val="D1FAE5"/>
             </a:solidFill>
             <a:prstDash val="solid"/>
           </a:ln>
@@ -11382,7 +11382,7 @@
             <a:r>
               <a:rPr lang="ar-SA" altLang="en-US" sz="1600" b="1" dirty="0">
                 <a:solidFill>
-                  <a:srgbClr val="12241F"/>
+                  <a:srgbClr val="0F172A"/>
                 </a:solidFill>
                 <a:latin typeface="Arial" pitchFamily="34" charset="0"/>
                 <a:ea typeface="Arial" pitchFamily="34" charset="-122"/>
@@ -11421,7 +11421,7 @@
             <a:r>
               <a:rPr lang="ar-SA" altLang="en-US" sz="1150" dirty="0">
                 <a:solidFill>
-                  <a:srgbClr val="4A5C56"/>
+                  <a:srgbClr val="475569"/>
                 </a:solidFill>
                 <a:latin typeface="Arial" pitchFamily="34" charset="0"/>
                 <a:ea typeface="Arial" pitchFamily="34" charset="-122"/>
@@ -11454,7 +11454,7 @@
           </a:solidFill>
           <a:ln w="9525">
             <a:solidFill>
-              <a:srgbClr val="D9E1DC"/>
+              <a:srgbClr val="E2E8F0"/>
             </a:solidFill>
             <a:prstDash val="solid"/>
           </a:ln>
@@ -11482,11 +11482,11 @@
             <a:avLst/>
           </a:prstGeom>
           <a:solidFill>
-            <a:srgbClr val="DCEDE6"/>
+            <a:srgbClr val="D1FAE5"/>
           </a:solidFill>
           <a:ln w="12700">
             <a:solidFill>
-              <a:srgbClr val="DCEDE6"/>
+              <a:srgbClr val="D1FAE5"/>
             </a:solidFill>
             <a:prstDash val="solid"/>
           </a:ln>
@@ -11543,7 +11543,7 @@
             <a:r>
               <a:rPr lang="ar-SA" altLang="en-US" sz="1600" b="1" dirty="0">
                 <a:solidFill>
-                  <a:srgbClr val="12241F"/>
+                  <a:srgbClr val="0F172A"/>
                 </a:solidFill>
                 <a:latin typeface="Arial" pitchFamily="34" charset="0"/>
                 <a:ea typeface="Arial" pitchFamily="34" charset="-122"/>
@@ -11582,7 +11582,7 @@
             <a:r>
               <a:rPr lang="ar-SA" altLang="en-US" sz="1150" dirty="0">
                 <a:solidFill>
-                  <a:srgbClr val="4A5C56"/>
+                  <a:srgbClr val="475569"/>
                 </a:solidFill>
                 <a:latin typeface="Arial" pitchFamily="34" charset="0"/>
                 <a:ea typeface="Arial" pitchFamily="34" charset="-122"/>
@@ -11621,7 +11621,7 @@
             <a:r>
               <a:rPr lang="ar-SA" altLang="en-US" sz="900" dirty="0">
                 <a:solidFill>
-                  <a:srgbClr val="7A8A84"/>
+                  <a:srgbClr val="64748B"/>
                 </a:solidFill>
                 <a:latin typeface="Arial" pitchFamily="34" charset="0"/>
                 <a:ea typeface="Arial" pitchFamily="34" charset="-122"/>
@@ -11660,7 +11660,7 @@
             <a:r>
               <a:rPr lang="en-US" sz="900" dirty="0">
                 <a:solidFill>
-                  <a:srgbClr val="7A8A84"/>
+                  <a:srgbClr val="64748B"/>
                 </a:solidFill>
                 <a:latin typeface="Arial" pitchFamily="34" charset="0"/>
                 <a:ea typeface="Arial" pitchFamily="34" charset="-122"/>
@@ -11731,7 +11731,7 @@
             <a:r>
               <a:rPr lang="ar-SA" altLang="en-US" sz="3000" b="1" dirty="0">
                 <a:solidFill>
-                  <a:srgbClr val="12241F"/>
+                  <a:srgbClr val="0F172A"/>
                 </a:solidFill>
                 <a:latin typeface="Arial" pitchFamily="34" charset="0"/>
                 <a:ea typeface="Arial" pitchFamily="34" charset="-122"/>
@@ -11770,7 +11770,7 @@
             <a:r>
               <a:rPr lang="ar-SA" altLang="en-US" sz="1400" dirty="0">
                 <a:solidFill>
-                  <a:srgbClr val="4A5C56"/>
+                  <a:srgbClr val="475569"/>
                 </a:solidFill>
                 <a:latin typeface="Arial" pitchFamily="34" charset="0"/>
                 <a:ea typeface="Arial" pitchFamily="34" charset="-122"/>
@@ -11799,11 +11799,11 @@
             </a:avLst>
           </a:prstGeom>
           <a:solidFill>
-            <a:srgbClr val="F4F7F5"/>
+            <a:srgbClr val="F8FAFC"/>
           </a:solidFill>
           <a:ln w="12700">
             <a:solidFill>
-              <a:srgbClr val="D9E1DC"/>
+              <a:srgbClr val="E2E8F0"/>
             </a:solidFill>
             <a:prstDash val="solid"/>
           </a:ln>
@@ -11836,7 +11836,7 @@
             <a:r>
               <a:rPr lang="ar-SA" altLang="en-US" sz="1600" b="1" dirty="0">
                 <a:solidFill>
-                  <a:srgbClr val="12241F"/>
+                  <a:srgbClr val="0F172A"/>
                 </a:solidFill>
                 <a:latin typeface="Arial" pitchFamily="34" charset="0"/>
                 <a:ea typeface="Arial" pitchFamily="34" charset="-122"/>
@@ -11875,7 +11875,7 @@
             <a:r>
               <a:rPr lang="ar-SA" altLang="en-US" sz="3000" b="1" dirty="0">
                 <a:solidFill>
-                  <a:srgbClr val="1D6B58"/>
+                  <a:srgbClr val="047857"/>
                 </a:solidFill>
                 <a:latin typeface="Arial" pitchFamily="34" charset="0"/>
                 <a:ea typeface="Arial" pitchFamily="34" charset="-122"/>
@@ -11914,7 +11914,7 @@
             <a:r>
               <a:rPr lang="ar-SA" altLang="en-US" sz="1100" dirty="0">
                 <a:solidFill>
-                  <a:srgbClr val="7A8A84"/>
+                  <a:srgbClr val="64748B"/>
                 </a:solidFill>
                 <a:latin typeface="Arial" pitchFamily="34" charset="0"/>
                 <a:ea typeface="Arial" pitchFamily="34" charset="-122"/>
@@ -11953,7 +11953,7 @@
             <a:r>
               <a:rPr lang="ar-SA" altLang="en-US" sz="1100" dirty="0">
                 <a:solidFill>
-                  <a:srgbClr val="4A5C56"/>
+                  <a:srgbClr val="475569"/>
                 </a:solidFill>
                 <a:latin typeface="Arial" pitchFamily="34" charset="0"/>
                 <a:ea typeface="Arial" pitchFamily="34" charset="-122"/>
@@ -11982,11 +11982,11 @@
             </a:avLst>
           </a:prstGeom>
           <a:solidFill>
-            <a:srgbClr val="1D6B58"/>
+            <a:srgbClr val="0F172A"/>
           </a:solidFill>
           <a:ln w="12700">
             <a:solidFill>
-              <a:srgbClr val="1D6B58"/>
+              <a:srgbClr val="0F172A"/>
             </a:solidFill>
             <a:prstDash val="solid"/>
           </a:ln>
@@ -12058,7 +12058,7 @@
             <a:r>
               <a:rPr lang="ar-SA" altLang="en-US" sz="3000" b="1" dirty="0">
                 <a:solidFill>
-                  <a:srgbClr val="FFFFFF"/>
+                  <a:srgbClr val="34D399"/>
                 </a:solidFill>
                 <a:latin typeface="Arial" pitchFamily="34" charset="0"/>
                 <a:ea typeface="Arial" pitchFamily="34" charset="-122"/>
@@ -12097,7 +12097,7 @@
             <a:r>
               <a:rPr lang="ar-SA" altLang="en-US" sz="1100" dirty="0">
                 <a:solidFill>
-                  <a:srgbClr val="CFE8DF"/>
+                  <a:srgbClr val="CBD5E1"/>
                 </a:solidFill>
                 <a:latin typeface="Arial" pitchFamily="34" charset="0"/>
                 <a:ea typeface="Arial" pitchFamily="34" charset="-122"/>
@@ -12165,11 +12165,11 @@
             </a:avLst>
           </a:prstGeom>
           <a:solidFill>
-            <a:srgbClr val="F4F7F5"/>
+            <a:srgbClr val="F8FAFC"/>
           </a:solidFill>
           <a:ln w="12700">
             <a:solidFill>
-              <a:srgbClr val="D9E1DC"/>
+              <a:srgbClr val="E2E8F0"/>
             </a:solidFill>
             <a:prstDash val="solid"/>
           </a:ln>
@@ -12202,7 +12202,7 @@
             <a:r>
               <a:rPr lang="ar-SA" altLang="en-US" sz="1600" b="1" dirty="0">
                 <a:solidFill>
-                  <a:srgbClr val="12241F"/>
+                  <a:srgbClr val="0F172A"/>
                 </a:solidFill>
                 <a:latin typeface="Arial" pitchFamily="34" charset="0"/>
                 <a:ea typeface="Arial" pitchFamily="34" charset="-122"/>
@@ -12241,7 +12241,7 @@
             <a:r>
               <a:rPr lang="ar-SA" altLang="en-US" sz="3000" b="1" dirty="0">
                 <a:solidFill>
-                  <a:srgbClr val="1D6B58"/>
+                  <a:srgbClr val="047857"/>
                 </a:solidFill>
                 <a:latin typeface="Arial" pitchFamily="34" charset="0"/>
                 <a:ea typeface="Arial" pitchFamily="34" charset="-122"/>
@@ -12280,7 +12280,7 @@
             <a:r>
               <a:rPr lang="ar-SA" altLang="en-US" sz="1100" dirty="0">
                 <a:solidFill>
-                  <a:srgbClr val="7A8A84"/>
+                  <a:srgbClr val="64748B"/>
                 </a:solidFill>
                 <a:latin typeface="Arial" pitchFamily="34" charset="0"/>
                 <a:ea typeface="Arial" pitchFamily="34" charset="-122"/>
@@ -12319,7 +12319,7 @@
             <a:r>
               <a:rPr lang="ar-SA" altLang="en-US" sz="1100" dirty="0">
                 <a:solidFill>
-                  <a:srgbClr val="4A5C56"/>
+                  <a:srgbClr val="475569"/>
                 </a:solidFill>
                 <a:latin typeface="Arial" pitchFamily="34" charset="0"/>
                 <a:ea typeface="Arial" pitchFamily="34" charset="-122"/>
@@ -12348,11 +12348,11 @@
             </a:avLst>
           </a:prstGeom>
           <a:solidFill>
-            <a:srgbClr val="F4F7F5"/>
+            <a:srgbClr val="F8FAFC"/>
           </a:solidFill>
           <a:ln w="12700">
             <a:solidFill>
-              <a:srgbClr val="D9E1DC"/>
+              <a:srgbClr val="E2E8F0"/>
             </a:solidFill>
             <a:prstDash val="solid"/>
           </a:ln>
@@ -12385,7 +12385,7 @@
             <a:r>
               <a:rPr lang="ar-SA" altLang="en-US" sz="1600" b="1" dirty="0">
                 <a:solidFill>
-                  <a:srgbClr val="12241F"/>
+                  <a:srgbClr val="0F172A"/>
                 </a:solidFill>
                 <a:latin typeface="Arial" pitchFamily="34" charset="0"/>
                 <a:ea typeface="Arial" pitchFamily="34" charset="-122"/>
@@ -12424,7 +12424,7 @@
             <a:r>
               <a:rPr lang="ar-SA" altLang="en-US" sz="3000" b="1" dirty="0">
                 <a:solidFill>
-                  <a:srgbClr val="1D6B58"/>
+                  <a:srgbClr val="047857"/>
                 </a:solidFill>
                 <a:latin typeface="Arial" pitchFamily="34" charset="0"/>
                 <a:ea typeface="Arial" pitchFamily="34" charset="-122"/>
@@ -12463,7 +12463,7 @@
             <a:r>
               <a:rPr lang="ar-SA" altLang="en-US" sz="1100" dirty="0">
                 <a:solidFill>
-                  <a:srgbClr val="7A8A84"/>
+                  <a:srgbClr val="64748B"/>
                 </a:solidFill>
                 <a:latin typeface="Arial" pitchFamily="34" charset="0"/>
                 <a:ea typeface="Arial" pitchFamily="34" charset="-122"/>
@@ -12502,7 +12502,7 @@
             <a:r>
               <a:rPr lang="ar-SA" altLang="en-US" sz="1100" dirty="0">
                 <a:solidFill>
-                  <a:srgbClr val="4A5C56"/>
+                  <a:srgbClr val="475569"/>
                 </a:solidFill>
                 <a:latin typeface="Arial" pitchFamily="34" charset="0"/>
                 <a:ea typeface="Arial" pitchFamily="34" charset="-122"/>
@@ -12541,7 +12541,7 @@
             <a:r>
               <a:rPr lang="ar-SA" altLang="en-US" sz="1250" dirty="0">
                 <a:solidFill>
-                  <a:srgbClr val="4A5C56"/>
+                  <a:srgbClr val="475569"/>
                 </a:solidFill>
                 <a:latin typeface="Arial" pitchFamily="34" charset="0"/>
                 <a:ea typeface="Arial" pitchFamily="34" charset="-122"/>
@@ -12580,7 +12580,7 @@
             <a:r>
               <a:rPr lang="ar-SA" altLang="en-US" sz="900" dirty="0">
                 <a:solidFill>
-                  <a:srgbClr val="7A8A84"/>
+                  <a:srgbClr val="64748B"/>
                 </a:solidFill>
                 <a:latin typeface="Arial" pitchFamily="34" charset="0"/>
                 <a:ea typeface="Arial" pitchFamily="34" charset="-122"/>
@@ -12619,7 +12619,7 @@
             <a:r>
               <a:rPr lang="en-US" sz="900" dirty="0">
                 <a:solidFill>
-                  <a:srgbClr val="7A8A84"/>
+                  <a:srgbClr val="64748B"/>
                 </a:solidFill>
                 <a:latin typeface="Arial" pitchFamily="34" charset="0"/>
                 <a:ea typeface="Arial" pitchFamily="34" charset="-122"/>

</xml_diff>